<commit_message>
fix: render ASCII art as images for pixel-perfect alignment
PowerPoint's text rendering can't maintain exact CJK:ASCII 2:1 width
ratio even with kerning disabled and EA font set. Switch arch-box
ASCII art to PIL image rendering using IPAGothic font, which correctly
preserves monospace alignment. Embedded as PNG in PPTX slides.
</commit_message>
<xml_diff>
--- a/HCCJP_71/AI時代の「本当の」ハイブリッドクラウド — エージェントが実現した、あの頃の夢.pptx
+++ b/HCCJP_71/AI時代の「本当の」ハイブリッドクラウド — エージェントが実現した、あの頃の夢.pptx
@@ -6205,67 +6205,30 @@
           </a:p>
         </p:txBody>
       </p:sp>
-      <p:sp>
-        <p:nvSpPr>
-          <p:cNvPr id="5" name="Rectangle 4"/>
-          <p:cNvSpPr/>
-          <p:nvPr/>
-        </p:nvSpPr>
-        <p:spPr>
-          <a:xfrm>
-            <a:off x="502920" y="1577340"/>
-            <a:ext cx="11183112" cy="3297555"/>
-          </a:xfrm>
-          <a:prstGeom prst="rect">
-            <a:avLst/>
-          </a:prstGeom>
-          <a:solidFill>
-            <a:srgbClr val="F5F5F5"/>
-          </a:solidFill>
-          <a:ln>
-            <a:noFill/>
-          </a:ln>
-        </p:spPr>
-        <p:style>
-          <a:lnRef idx="1">
-            <a:schemeClr val="accent1"/>
-          </a:lnRef>
-          <a:fillRef idx="3">
-            <a:schemeClr val="accent1"/>
-          </a:fillRef>
-          <a:effectRef idx="2">
-            <a:schemeClr val="accent1"/>
-          </a:effectRef>
-          <a:fontRef idx="minor">
-            <a:schemeClr val="lt1"/>
-          </a:fontRef>
-        </p:style>
-        <p:txBody>
-          <a:bodyPr rtlCol="0" anchor="ctr" wrap="none"/>
-          <a:lstStyle/>
-          <a:p>
-            <a:pPr algn="ctr"/>
-            <a:r>
-              <a:rPr sz="1900" kern="0" spc="0">
-                <a:solidFill>
-                  <a:srgbClr val="323130"/>
-                </a:solidFill>
-                <a:latin typeface="MS Gothic"/>
-                <a:ea typeface="MS Gothic"/>
-              </a:rPr>
-              <a:t>+-------------------------------------------------------+
-|                  Microsoft 365 (SaaS)                 |
-|                                                       |
-| +------------+   +--------------+   +--------------+  |
-| |   OpenAI   |   | M365 Copilot |   |    WorkIQ    |  |
-| |  (モデル)  |&lt;--|(エージェント)|&lt;--| SP/Teams/    |  |
-| +------------+   +--------------+   | Outlook/OD   |  |
-|                                     +--------------+  |
-+-------------------------------------------------------+</a:t>
-            </a:r>
-          </a:p>
-        </p:txBody>
-      </p:sp>
+      <p:pic>
+        <p:nvPicPr>
+          <p:cNvPr id="5" name="Picture 4" descr="image.png"/>
+          <p:cNvPicPr>
+            <a:picLocks noChangeAspect="1"/>
+          </p:cNvPicPr>
+          <p:nvPr/>
+        </p:nvPicPr>
+        <p:blipFill>
+          <a:blip r:embed="rId2"/>
+          <a:stretch>
+            <a:fillRect/>
+          </a:stretch>
+        </p:blipFill>
+        <p:spPr>
+          <a:xfrm>
+            <a:off x="504444" y="1577340"/>
+            <a:ext cx="11180064" cy="2767584"/>
+          </a:xfrm>
+          <a:prstGeom prst="rect">
+            <a:avLst/>
+          </a:prstGeom>
+        </p:spPr>
+      </p:pic>
       <p:sp>
         <p:nvSpPr>
           <p:cNvPr id="6" name="TextBox 5"/>
@@ -6274,8 +6237,8 @@
         </p:nvSpPr>
         <p:spPr>
           <a:xfrm>
-            <a:off x="502920" y="4966335"/>
-            <a:ext cx="11183112" cy="1022984"/>
+            <a:off x="502920" y="4436364"/>
+            <a:ext cx="11183112" cy="1552956"/>
           </a:xfrm>
           <a:prstGeom prst="rect">
             <a:avLst/>
@@ -6617,252 +6580,33 @@
           </a:p>
         </p:txBody>
       </p:sp>
-      <p:sp>
-        <p:nvSpPr>
-          <p:cNvPr id="5" name="Rectangle 4"/>
-          <p:cNvSpPr/>
-          <p:nvPr/>
-        </p:nvSpPr>
-        <p:spPr>
-          <a:xfrm>
-            <a:off x="502920" y="1577340"/>
-            <a:ext cx="11183112" cy="3726180"/>
-          </a:xfrm>
-          <a:prstGeom prst="rect">
-            <a:avLst/>
-          </a:prstGeom>
-          <a:solidFill>
-            <a:srgbClr val="F5F5F5"/>
-          </a:solidFill>
-          <a:ln>
-            <a:noFill/>
-          </a:ln>
-        </p:spPr>
-        <p:style>
-          <a:lnRef idx="1">
-            <a:schemeClr val="accent1"/>
-          </a:lnRef>
-          <a:fillRef idx="3">
-            <a:schemeClr val="accent1"/>
-          </a:fillRef>
-          <a:effectRef idx="2">
-            <a:schemeClr val="accent1"/>
-          </a:effectRef>
-          <a:fontRef idx="minor">
-            <a:schemeClr val="lt1"/>
-          </a:fontRef>
-        </p:style>
-        <p:txBody>
-          <a:bodyPr rtlCol="0" anchor="ctr" wrap="none"/>
-          <a:lstStyle/>
-          <a:p>
-            <a:pPr algn="ctr"/>
-            <a:r>
-              <a:rPr sz="1400" kern="0" spc="0">
-                <a:solidFill>
-                  <a:srgbClr val="323130"/>
-                </a:solidFill>
-                <a:latin typeface="MS Gothic"/>
-                <a:ea typeface="MS Gothic"/>
-              </a:rPr>
-              <a:t>+----------------------------------------------------+ 
-|                   Azure (クラウド基盤)              |
-|                                                     |
-| +--------------------+   +-----------------------+  |
-| | Microsoft Foundry  |   | Azure AI Search       |  |
-| | (モデル)           |&lt;--| (ベクトルストア)      |  |
-| +--------------------+   | + Blob Storage        |  |
-|          ^               +-----------------------+  |
-|          |                                          |
-| +--------+-----------+                              |
-| | Azure App Service  |                              |
-| | (自作Webアプリ)    |                              |
-| +--------------------+                              |
-+----------------------------------------------------+ </a:t>
-            </a:r>
-          </a:p>
-        </p:txBody>
-      </p:sp>
+      <p:pic>
+        <p:nvPicPr>
+          <p:cNvPr id="5" name="Picture 4" descr="image.png"/>
+          <p:cNvPicPr>
+            <a:picLocks noChangeAspect="1"/>
+          </p:cNvPicPr>
+          <p:nvPr/>
+        </p:nvPicPr>
+        <p:blipFill>
+          <a:blip r:embed="rId2"/>
+          <a:stretch>
+            <a:fillRect/>
+          </a:stretch>
+        </p:blipFill>
+        <p:spPr>
+          <a:xfrm>
+            <a:off x="504444" y="1577340"/>
+            <a:ext cx="11180064" cy="4169663"/>
+          </a:xfrm>
+          <a:prstGeom prst="rect">
+            <a:avLst/>
+          </a:prstGeom>
+        </p:spPr>
+      </p:pic>
       <p:sp>
         <p:nvSpPr>
           <p:cNvPr id="6" name="TextBox 5"/>
-          <p:cNvSpPr txBox="1"/>
-          <p:nvPr/>
-        </p:nvSpPr>
-        <p:spPr>
-          <a:xfrm>
-            <a:off x="502920" y="5394960"/>
-            <a:ext cx="11183112" cy="594359"/>
-          </a:xfrm>
-          <a:prstGeom prst="rect">
-            <a:avLst/>
-          </a:prstGeom>
-          <a:noFill/>
-        </p:spPr>
-        <p:txBody>
-          <a:bodyPr wrap="square">
-            <a:normAutofit/>
-          </a:bodyPr>
-          <a:lstStyle/>
-          <a:p>
-            <a:pPr>
-              <a:spcAft>
-                <a:spcPts val="500"/>
-              </a:spcAft>
-            </a:pPr>
-            <a:r>
-              <a:rPr sz="2100">
-                <a:solidFill>
-                  <a:srgbClr val="323130"/>
-                </a:solidFill>
-                <a:latin typeface="Meiryo"/>
-                <a:ea typeface="Meiryo"/>
-              </a:rPr>
-              <a:t>• </a:t>
-            </a:r>
-            <a:r>
-              <a:rPr sz="2100" b="1">
-                <a:solidFill>
-                  <a:srgbClr val="323130"/>
-                </a:solidFill>
-                <a:latin typeface="Meiryo"/>
-                <a:ea typeface="Meiryo"/>
-              </a:rPr>
-              <a:t>モデル</a:t>
-            </a:r>
-            <a:r>
-              <a:rPr sz="2100">
-                <a:solidFill>
-                  <a:srgbClr val="323130"/>
-                </a:solidFill>
-                <a:latin typeface="Meiryo"/>
-                <a:ea typeface="Meiryo"/>
-              </a:rPr>
-              <a:t> </a:t>
-            </a:r>
-            <a:r>
-              <a:rPr sz="1700" b="1">
-                <a:solidFill>
-                  <a:srgbClr val="1565C0"/>
-                </a:solidFill>
-                <a:latin typeface="Meiryo"/>
-                <a:ea typeface="Meiryo"/>
-              </a:rPr>
-              <a:t>クラウド基盤</a:t>
-            </a:r>
-            <a:r>
-              <a:rPr sz="2100">
-                <a:solidFill>
-                  <a:srgbClr val="323130"/>
-                </a:solidFill>
-                <a:latin typeface="Meiryo"/>
-                <a:ea typeface="Meiryo"/>
-              </a:rPr>
-              <a:t> / </a:t>
-            </a:r>
-            <a:r>
-              <a:rPr sz="2100" b="1">
-                <a:solidFill>
-                  <a:srgbClr val="323130"/>
-                </a:solidFill>
-                <a:latin typeface="Meiryo"/>
-                <a:ea typeface="Meiryo"/>
-              </a:rPr>
-              <a:t>エージェントソフト</a:t>
-            </a:r>
-            <a:r>
-              <a:rPr sz="2100">
-                <a:solidFill>
-                  <a:srgbClr val="323130"/>
-                </a:solidFill>
-                <a:latin typeface="Meiryo"/>
-                <a:ea typeface="Meiryo"/>
-              </a:rPr>
-              <a:t> </a:t>
-            </a:r>
-            <a:r>
-              <a:rPr sz="1700" b="1">
-                <a:solidFill>
-                  <a:srgbClr val="1565C0"/>
-                </a:solidFill>
-                <a:latin typeface="Meiryo"/>
-                <a:ea typeface="Meiryo"/>
-              </a:rPr>
-              <a:t>クラウド基盤</a:t>
-            </a:r>
-            <a:r>
-              <a:rPr sz="2100">
-                <a:solidFill>
-                  <a:srgbClr val="323130"/>
-                </a:solidFill>
-                <a:latin typeface="Meiryo"/>
-                <a:ea typeface="Meiryo"/>
-              </a:rPr>
-              <a:t> / </a:t>
-            </a:r>
-            <a:r>
-              <a:rPr sz="2100" b="1">
-                <a:solidFill>
-                  <a:srgbClr val="323130"/>
-                </a:solidFill>
-                <a:latin typeface="Meiryo"/>
-                <a:ea typeface="Meiryo"/>
-              </a:rPr>
-              <a:t>コンテキスト</a:t>
-            </a:r>
-            <a:r>
-              <a:rPr sz="2100">
-                <a:solidFill>
-                  <a:srgbClr val="323130"/>
-                </a:solidFill>
-                <a:latin typeface="Meiryo"/>
-                <a:ea typeface="Meiryo"/>
-              </a:rPr>
-              <a:t> </a:t>
-            </a:r>
-            <a:r>
-              <a:rPr sz="1700" b="1">
-                <a:solidFill>
-                  <a:srgbClr val="1565C0"/>
-                </a:solidFill>
-                <a:latin typeface="Meiryo"/>
-                <a:ea typeface="Meiryo"/>
-              </a:rPr>
-              <a:t>クラウド基盤</a:t>
-            </a:r>
-          </a:p>
-          <a:p>
-            <a:pPr>
-              <a:spcAft>
-                <a:spcPts val="500"/>
-              </a:spcAft>
-            </a:pPr>
-            <a:r>
-              <a:rPr sz="2100">
-                <a:solidFill>
-                  <a:srgbClr val="323130"/>
-                </a:solidFill>
-                <a:latin typeface="Meiryo"/>
-                <a:ea typeface="Meiryo"/>
-              </a:rPr>
-              <a:t>• → </a:t>
-            </a:r>
-            <a:r>
-              <a:rPr sz="2100" b="1">
-                <a:solidFill>
-                  <a:srgbClr val="323130"/>
-                </a:solidFill>
-                <a:latin typeface="Meiryo"/>
-                <a:ea typeface="Meiryo"/>
-              </a:rPr>
-              <a:t>すべてクラウド基盤。自前で構築・管理する典型的なエンタープライズ構成</a:t>
-            </a:r>
-          </a:p>
-        </p:txBody>
-      </p:sp>
-      <p:sp>
-        <p:nvSpPr>
-          <p:cNvPr id="7" name="TextBox 6"/>
           <p:cNvSpPr txBox="1"/>
           <p:nvPr/>
         </p:nvSpPr>
@@ -7034,252 +6778,33 @@
           </a:p>
         </p:txBody>
       </p:sp>
-      <p:sp>
-        <p:nvSpPr>
-          <p:cNvPr id="5" name="Rectangle 4"/>
-          <p:cNvSpPr/>
-          <p:nvPr/>
-        </p:nvSpPr>
-        <p:spPr>
-          <a:xfrm>
-            <a:off x="502920" y="1577340"/>
-            <a:ext cx="11183112" cy="3726180"/>
-          </a:xfrm>
-          <a:prstGeom prst="rect">
-            <a:avLst/>
-          </a:prstGeom>
-          <a:solidFill>
-            <a:srgbClr val="F5F5F5"/>
-          </a:solidFill>
-          <a:ln>
-            <a:noFill/>
-          </a:ln>
-        </p:spPr>
-        <p:style>
-          <a:lnRef idx="1">
-            <a:schemeClr val="accent1"/>
-          </a:lnRef>
-          <a:fillRef idx="3">
-            <a:schemeClr val="accent1"/>
-          </a:fillRef>
-          <a:effectRef idx="2">
-            <a:schemeClr val="accent1"/>
-          </a:effectRef>
-          <a:fontRef idx="minor">
-            <a:schemeClr val="lt1"/>
-          </a:fontRef>
-        </p:style>
-        <p:txBody>
-          <a:bodyPr rtlCol="0" anchor="ctr" wrap="none"/>
-          <a:lstStyle/>
-          <a:p>
-            <a:pPr algn="ctr"/>
-            <a:r>
-              <a:rPr sz="1400" kern="0" spc="0">
-                <a:solidFill>
-                  <a:srgbClr val="323130"/>
-                </a:solidFill>
-                <a:latin typeface="MS Gothic"/>
-                <a:ea typeface="MS Gothic"/>
-              </a:rPr>
-              <a:t>+----------------------------------------------------+  
-|                 社内データセンター (オンプレ)        |
-|                                                      |
-| +--------------------+   +-----------------------+   |
-| | Ollama / vLLM      |   | PostgreSQL pgvector   |   |
-| | (GPU搭載サーバー)  |&lt;--| / Elasticsearch       |   |
-| +--------------------+   | (ベクトルストア)      |   |
-|          ^               +-----------------------+   |
-|          |                                           |
-| +--------+-----------+                               |
-| | 自作Webアプリ      |                               |
-| | (社内サーバー)     |                               |
-| +--------------------+                               |
-+----------------------------------------------------+  </a:t>
-            </a:r>
-          </a:p>
-        </p:txBody>
-      </p:sp>
+      <p:pic>
+        <p:nvPicPr>
+          <p:cNvPr id="5" name="Picture 4" descr="image.png"/>
+          <p:cNvPicPr>
+            <a:picLocks noChangeAspect="1"/>
+          </p:cNvPicPr>
+          <p:nvPr/>
+        </p:nvPicPr>
+        <p:blipFill>
+          <a:blip r:embed="rId2"/>
+          <a:stretch>
+            <a:fillRect/>
+          </a:stretch>
+        </p:blipFill>
+        <p:spPr>
+          <a:xfrm>
+            <a:off x="504444" y="1577340"/>
+            <a:ext cx="11180064" cy="4169663"/>
+          </a:xfrm>
+          <a:prstGeom prst="rect">
+            <a:avLst/>
+          </a:prstGeom>
+        </p:spPr>
+      </p:pic>
       <p:sp>
         <p:nvSpPr>
           <p:cNvPr id="6" name="TextBox 5"/>
-          <p:cNvSpPr txBox="1"/>
-          <p:nvPr/>
-        </p:nvSpPr>
-        <p:spPr>
-          <a:xfrm>
-            <a:off x="502920" y="5394960"/>
-            <a:ext cx="11183112" cy="594359"/>
-          </a:xfrm>
-          <a:prstGeom prst="rect">
-            <a:avLst/>
-          </a:prstGeom>
-          <a:noFill/>
-        </p:spPr>
-        <p:txBody>
-          <a:bodyPr wrap="square">
-            <a:normAutofit/>
-          </a:bodyPr>
-          <a:lstStyle/>
-          <a:p>
-            <a:pPr>
-              <a:spcAft>
-                <a:spcPts val="500"/>
-              </a:spcAft>
-            </a:pPr>
-            <a:r>
-              <a:rPr sz="2100">
-                <a:solidFill>
-                  <a:srgbClr val="323130"/>
-                </a:solidFill>
-                <a:latin typeface="Meiryo"/>
-                <a:ea typeface="Meiryo"/>
-              </a:rPr>
-              <a:t>• </a:t>
-            </a:r>
-            <a:r>
-              <a:rPr sz="2100" b="1">
-                <a:solidFill>
-                  <a:srgbClr val="323130"/>
-                </a:solidFill>
-                <a:latin typeface="Meiryo"/>
-                <a:ea typeface="Meiryo"/>
-              </a:rPr>
-              <a:t>モデル</a:t>
-            </a:r>
-            <a:r>
-              <a:rPr sz="2100">
-                <a:solidFill>
-                  <a:srgbClr val="323130"/>
-                </a:solidFill>
-                <a:latin typeface="Meiryo"/>
-                <a:ea typeface="Meiryo"/>
-              </a:rPr>
-              <a:t> </a:t>
-            </a:r>
-            <a:r>
-              <a:rPr sz="1700" b="1">
-                <a:solidFill>
-                  <a:srgbClr val="2E7D32"/>
-                </a:solidFill>
-                <a:latin typeface="Meiryo"/>
-                <a:ea typeface="Meiryo"/>
-              </a:rPr>
-              <a:t>オンプレ</a:t>
-            </a:r>
-            <a:r>
-              <a:rPr sz="2100">
-                <a:solidFill>
-                  <a:srgbClr val="323130"/>
-                </a:solidFill>
-                <a:latin typeface="Meiryo"/>
-                <a:ea typeface="Meiryo"/>
-              </a:rPr>
-              <a:t> / </a:t>
-            </a:r>
-            <a:r>
-              <a:rPr sz="2100" b="1">
-                <a:solidFill>
-                  <a:srgbClr val="323130"/>
-                </a:solidFill>
-                <a:latin typeface="Meiryo"/>
-                <a:ea typeface="Meiryo"/>
-              </a:rPr>
-              <a:t>エージェントソフト</a:t>
-            </a:r>
-            <a:r>
-              <a:rPr sz="2100">
-                <a:solidFill>
-                  <a:srgbClr val="323130"/>
-                </a:solidFill>
-                <a:latin typeface="Meiryo"/>
-                <a:ea typeface="Meiryo"/>
-              </a:rPr>
-              <a:t> </a:t>
-            </a:r>
-            <a:r>
-              <a:rPr sz="1700" b="1">
-                <a:solidFill>
-                  <a:srgbClr val="2E7D32"/>
-                </a:solidFill>
-                <a:latin typeface="Meiryo"/>
-                <a:ea typeface="Meiryo"/>
-              </a:rPr>
-              <a:t>オンプレ</a:t>
-            </a:r>
-            <a:r>
-              <a:rPr sz="2100">
-                <a:solidFill>
-                  <a:srgbClr val="323130"/>
-                </a:solidFill>
-                <a:latin typeface="Meiryo"/>
-                <a:ea typeface="Meiryo"/>
-              </a:rPr>
-              <a:t> / </a:t>
-            </a:r>
-            <a:r>
-              <a:rPr sz="2100" b="1">
-                <a:solidFill>
-                  <a:srgbClr val="323130"/>
-                </a:solidFill>
-                <a:latin typeface="Meiryo"/>
-                <a:ea typeface="Meiryo"/>
-              </a:rPr>
-              <a:t>コンテキスト</a:t>
-            </a:r>
-            <a:r>
-              <a:rPr sz="2100">
-                <a:solidFill>
-                  <a:srgbClr val="323130"/>
-                </a:solidFill>
-                <a:latin typeface="Meiryo"/>
-                <a:ea typeface="Meiryo"/>
-              </a:rPr>
-              <a:t> </a:t>
-            </a:r>
-            <a:r>
-              <a:rPr sz="1700" b="1">
-                <a:solidFill>
-                  <a:srgbClr val="2E7D32"/>
-                </a:solidFill>
-                <a:latin typeface="Meiryo"/>
-                <a:ea typeface="Meiryo"/>
-              </a:rPr>
-              <a:t>オンプレ</a:t>
-            </a:r>
-          </a:p>
-          <a:p>
-            <a:pPr>
-              <a:spcAft>
-                <a:spcPts val="500"/>
-              </a:spcAft>
-            </a:pPr>
-            <a:r>
-              <a:rPr sz="2100">
-                <a:solidFill>
-                  <a:srgbClr val="323130"/>
-                </a:solidFill>
-                <a:latin typeface="Meiryo"/>
-                <a:ea typeface="Meiryo"/>
-              </a:rPr>
-              <a:t>• → </a:t>
-            </a:r>
-            <a:r>
-              <a:rPr sz="2100" b="1">
-                <a:solidFill>
-                  <a:srgbClr val="323130"/>
-                </a:solidFill>
-                <a:latin typeface="Meiryo"/>
-                <a:ea typeface="Meiryo"/>
-              </a:rPr>
-              <a:t>すべてオンプレ。データを外に出せない要件がある場合の構成</a:t>
-            </a:r>
-          </a:p>
-        </p:txBody>
-      </p:sp>
-      <p:sp>
-        <p:nvSpPr>
-          <p:cNvPr id="7" name="TextBox 6"/>
           <p:cNvSpPr txBox="1"/>
           <p:nvPr/>
         </p:nvSpPr>
@@ -7451,70 +6976,30 @@
           </a:p>
         </p:txBody>
       </p:sp>
-      <p:sp>
-        <p:nvSpPr>
-          <p:cNvPr id="5" name="Rectangle 4"/>
-          <p:cNvSpPr/>
-          <p:nvPr/>
-        </p:nvSpPr>
-        <p:spPr>
-          <a:xfrm>
-            <a:off x="502920" y="1577340"/>
-            <a:ext cx="11183112" cy="3246120"/>
-          </a:xfrm>
-          <a:prstGeom prst="rect">
-            <a:avLst/>
-          </a:prstGeom>
-          <a:solidFill>
-            <a:srgbClr val="F5F5F5"/>
-          </a:solidFill>
-          <a:ln>
-            <a:noFill/>
-          </a:ln>
-        </p:spPr>
-        <p:style>
-          <a:lnRef idx="1">
-            <a:schemeClr val="accent1"/>
-          </a:lnRef>
-          <a:fillRef idx="3">
-            <a:schemeClr val="accent1"/>
-          </a:fillRef>
-          <a:effectRef idx="2">
-            <a:schemeClr val="accent1"/>
-          </a:effectRef>
-          <a:fontRef idx="minor">
-            <a:schemeClr val="lt1"/>
-          </a:fontRef>
-        </p:style>
-        <p:txBody>
-          <a:bodyPr rtlCol="0" anchor="ctr" wrap="none"/>
-          <a:lstStyle/>
-          <a:p>
-            <a:pPr algn="ctr"/>
-            <a:r>
-              <a:rPr sz="1400" kern="0" spc="0">
-                <a:solidFill>
-                  <a:srgbClr val="323130"/>
-                </a:solidFill>
-                <a:latin typeface="MS Gothic"/>
-                <a:ea typeface="MS Gothic"/>
-              </a:rPr>
-              <a:t>+-------------------+          +------------------------+
-|    ローカル       |          |    GitHub (クラウド)   |
-|                   |          |                        |
-| +---------------+ |          | Repository             |
-| | ソースコード  | |   API    | Issues / Discussions   |
-| | copilot-      |&lt;|---------&gt;| Copilot Spaces         |
-| | instructions  | |          +------------------------+
-| +---------------+ |          | モデル選択             |
-|        |          |          |  GPT / Claude /        |
-|   Copilot CLI     |          |  Gemini                |
-|  (エージェント)   |          +------------------------+
-+-------------------+</a:t>
-            </a:r>
-          </a:p>
-        </p:txBody>
-      </p:sp>
+      <p:pic>
+        <p:nvPicPr>
+          <p:cNvPr id="5" name="Picture 4" descr="image.png"/>
+          <p:cNvPicPr>
+            <a:picLocks noChangeAspect="1"/>
+          </p:cNvPicPr>
+          <p:nvPr/>
+        </p:nvPicPr>
+        <p:blipFill>
+          <a:blip r:embed="rId2"/>
+          <a:stretch>
+            <a:fillRect/>
+          </a:stretch>
+        </p:blipFill>
+        <p:spPr>
+          <a:xfrm>
+            <a:off x="504444" y="1577340"/>
+            <a:ext cx="11180064" cy="3608832"/>
+          </a:xfrm>
+          <a:prstGeom prst="rect">
+            <a:avLst/>
+          </a:prstGeom>
+        </p:spPr>
+      </p:pic>
       <p:sp>
         <p:nvSpPr>
           <p:cNvPr id="6" name="TextBox 5"/>
@@ -7523,8 +7008,8 @@
         </p:nvSpPr>
         <p:spPr>
           <a:xfrm>
-            <a:off x="502920" y="4914900"/>
-            <a:ext cx="11183112" cy="1074419"/>
+            <a:off x="502920" y="5277612"/>
+            <a:ext cx="11183112" cy="711708"/>
           </a:xfrm>
           <a:prstGeom prst="rect">
             <a:avLst/>
@@ -7903,71 +7388,30 @@
           </a:p>
         </p:txBody>
       </p:sp>
-      <p:sp>
-        <p:nvSpPr>
-          <p:cNvPr id="5" name="Rectangle 4"/>
-          <p:cNvSpPr/>
-          <p:nvPr/>
-        </p:nvSpPr>
-        <p:spPr>
-          <a:xfrm>
-            <a:off x="502920" y="1577340"/>
-            <a:ext cx="11183112" cy="3040380"/>
-          </a:xfrm>
-          <a:prstGeom prst="rect">
-            <a:avLst/>
-          </a:prstGeom>
-          <a:solidFill>
-            <a:srgbClr val="F5F5F5"/>
-          </a:solidFill>
-          <a:ln>
-            <a:noFill/>
-          </a:ln>
-        </p:spPr>
-        <p:style>
-          <a:lnRef idx="1">
-            <a:schemeClr val="accent1"/>
-          </a:lnRef>
-          <a:fillRef idx="3">
-            <a:schemeClr val="accent1"/>
-          </a:fillRef>
-          <a:effectRef idx="2">
-            <a:schemeClr val="accent1"/>
-          </a:effectRef>
-          <a:fontRef idx="minor">
-            <a:schemeClr val="lt1"/>
-          </a:fontRef>
-        </p:style>
-        <p:txBody>
-          <a:bodyPr rtlCol="0" anchor="ctr" wrap="none"/>
-          <a:lstStyle/>
-          <a:p>
-            <a:pPr algn="ctr"/>
-            <a:r>
-              <a:rPr sz="1200" kern="0" spc="0">
-                <a:solidFill>
-                  <a:srgbClr val="323130"/>
-                </a:solidFill>
-                <a:latin typeface="MS Gothic"/>
-                <a:ea typeface="MS Gothic"/>
-              </a:rPr>
-              <a:t>+-------------------+          +------------------------+
-|    ローカル       |          |       クラウド         |
-|                   |          |                        |
-| +---------------+ |          | Anthropic API (推論)   |
-| | Obsidian      | |   API    | Todoist API            |
-| | CLAUDE.md     |&lt;|---------&gt;| Google Calendar API    |
-| | ソースコード  | |          | GitHub                 |
-| | skills/       | |          | Azure                  |
-| +---------------+ |          | Discord API            |
-|        |          |          +------------------------+
-|   Claude Code     |
-|  (エージェント)   |
-+-------------------+</a:t>
-            </a:r>
-          </a:p>
-        </p:txBody>
-      </p:sp>
+      <p:pic>
+        <p:nvPicPr>
+          <p:cNvPr id="5" name="Picture 4" descr="image.png"/>
+          <p:cNvPicPr>
+            <a:picLocks noChangeAspect="1"/>
+          </p:cNvPicPr>
+          <p:nvPr/>
+        </p:nvPicPr>
+        <p:blipFill>
+          <a:blip r:embed="rId2"/>
+          <a:stretch>
+            <a:fillRect/>
+          </a:stretch>
+        </p:blipFill>
+        <p:spPr>
+          <a:xfrm>
+            <a:off x="504444" y="1577340"/>
+            <a:ext cx="11180064" cy="3889247"/>
+          </a:xfrm>
+          <a:prstGeom prst="rect">
+            <a:avLst/>
+          </a:prstGeom>
+        </p:spPr>
+      </p:pic>
       <p:sp>
         <p:nvSpPr>
           <p:cNvPr id="6" name="TextBox 5"/>
@@ -7976,8 +7420,8 @@
         </p:nvSpPr>
         <p:spPr>
           <a:xfrm>
-            <a:off x="502920" y="4709160"/>
-            <a:ext cx="11183112" cy="1280159"/>
+            <a:off x="502920" y="5558028"/>
+            <a:ext cx="11183112" cy="431292"/>
           </a:xfrm>
           <a:prstGeom prst="rect">
             <a:avLst/>
@@ -8373,290 +7817,33 @@
           </a:p>
         </p:txBody>
       </p:sp>
-      <p:sp>
-        <p:nvSpPr>
-          <p:cNvPr id="5" name="Rectangle 4"/>
-          <p:cNvSpPr/>
-          <p:nvPr/>
-        </p:nvSpPr>
-        <p:spPr>
-          <a:xfrm>
-            <a:off x="502920" y="2194560"/>
-            <a:ext cx="11183112" cy="2937510"/>
-          </a:xfrm>
-          <a:prstGeom prst="rect">
-            <a:avLst/>
-          </a:prstGeom>
-          <a:solidFill>
-            <a:srgbClr val="F5F5F5"/>
-          </a:solidFill>
-          <a:ln>
-            <a:noFill/>
-          </a:ln>
-        </p:spPr>
-        <p:style>
-          <a:lnRef idx="1">
-            <a:schemeClr val="accent1"/>
-          </a:lnRef>
-          <a:fillRef idx="3">
-            <a:schemeClr val="accent1"/>
-          </a:fillRef>
-          <a:effectRef idx="2">
-            <a:schemeClr val="accent1"/>
-          </a:effectRef>
-          <a:fontRef idx="minor">
-            <a:schemeClr val="lt1"/>
-          </a:fontRef>
-        </p:style>
-        <p:txBody>
-          <a:bodyPr rtlCol="0" anchor="ctr" wrap="none"/>
-          <a:lstStyle/>
-          <a:p>
-            <a:pPr algn="ctr"/>
-            <a:r>
-              <a:rPr sz="1000" kern="0" spc="0">
-                <a:solidFill>
-                  <a:srgbClr val="323130"/>
-                </a:solidFill>
-                <a:latin typeface="MS Gothic"/>
-                <a:ea typeface="MS Gothic"/>
-              </a:rPr>
-              <a:t>+------------------------+       +----------------------------+
-|         Azure          |       |       オンプレミス         |
-|                        |       |                            |
-| +--------------------+ | HTTPS |  https://spark.xxx.ts.net  |
-| | Azure App Service  |-|------&gt;|            |               |
-| | (自作エージェント) | |       |            v Tailscale     |
-| +--------------------+ |       | +------------------------+ |
-|          |             |       | |       DGX Spark        | |
-|          | Fallback    |       | |   Ollama + LiteLLM     | |
-|          v             |       | +------------------------+ |
-| +--------------------+ |       |                            |
-| | Microsoft Foundry  | |       +----------------------------+
-| | (従量課金)         | |
-| +--------------------+ |
-+------------------------+</a:t>
-            </a:r>
-          </a:p>
-        </p:txBody>
-      </p:sp>
+      <p:pic>
+        <p:nvPicPr>
+          <p:cNvPr id="5" name="Picture 4" descr="image.png"/>
+          <p:cNvPicPr>
+            <a:picLocks noChangeAspect="1"/>
+          </p:cNvPicPr>
+          <p:nvPr/>
+        </p:nvPicPr>
+        <p:blipFill>
+          <a:blip r:embed="rId2"/>
+          <a:stretch>
+            <a:fillRect/>
+          </a:stretch>
+        </p:blipFill>
+        <p:spPr>
+          <a:xfrm>
+            <a:off x="504444" y="2194560"/>
+            <a:ext cx="11180064" cy="3794759"/>
+          </a:xfrm>
+          <a:prstGeom prst="rect">
+            <a:avLst/>
+          </a:prstGeom>
+        </p:spPr>
+      </p:pic>
       <p:sp>
         <p:nvSpPr>
           <p:cNvPr id="6" name="TextBox 5"/>
-          <p:cNvSpPr txBox="1"/>
-          <p:nvPr/>
-        </p:nvSpPr>
-        <p:spPr>
-          <a:xfrm>
-            <a:off x="502920" y="5223509"/>
-            <a:ext cx="11183112" cy="765810"/>
-          </a:xfrm>
-          <a:prstGeom prst="rect">
-            <a:avLst/>
-          </a:prstGeom>
-          <a:noFill/>
-        </p:spPr>
-        <p:txBody>
-          <a:bodyPr wrap="square">
-            <a:normAutofit/>
-          </a:bodyPr>
-          <a:lstStyle/>
-          <a:p>
-            <a:pPr>
-              <a:spcAft>
-                <a:spcPts val="300"/>
-              </a:spcAft>
-            </a:pPr>
-            <a:r>
-              <a:rPr sz="1500">
-                <a:solidFill>
-                  <a:srgbClr val="323130"/>
-                </a:solidFill>
-                <a:latin typeface="Meiryo"/>
-                <a:ea typeface="Meiryo"/>
-              </a:rPr>
-              <a:t>• </a:t>
-            </a:r>
-            <a:r>
-              <a:rPr sz="1500" b="1">
-                <a:solidFill>
-                  <a:srgbClr val="323130"/>
-                </a:solidFill>
-                <a:latin typeface="Meiryo"/>
-                <a:ea typeface="Meiryo"/>
-              </a:rPr>
-              <a:t>モデル</a:t>
-            </a:r>
-            <a:r>
-              <a:rPr sz="1500">
-                <a:solidFill>
-                  <a:srgbClr val="323130"/>
-                </a:solidFill>
-                <a:latin typeface="Meiryo"/>
-                <a:ea typeface="Meiryo"/>
-              </a:rPr>
-              <a:t> </a:t>
-            </a:r>
-            <a:r>
-              <a:rPr sz="1200" b="1">
-                <a:solidFill>
-                  <a:srgbClr val="2E7D32"/>
-                </a:solidFill>
-                <a:latin typeface="Meiryo"/>
-                <a:ea typeface="Meiryo"/>
-              </a:rPr>
-              <a:t>オンプレ</a:t>
-            </a:r>
-            <a:r>
-              <a:rPr sz="1500">
-                <a:solidFill>
-                  <a:srgbClr val="323130"/>
-                </a:solidFill>
-                <a:latin typeface="Meiryo"/>
-                <a:ea typeface="Meiryo"/>
-              </a:rPr>
-              <a:t> DGX Spark + </a:t>
-            </a:r>
-            <a:r>
-              <a:rPr sz="1200" b="1">
-                <a:solidFill>
-                  <a:srgbClr val="1565C0"/>
-                </a:solidFill>
-                <a:latin typeface="Meiryo"/>
-                <a:ea typeface="Meiryo"/>
-              </a:rPr>
-              <a:t>クラウド基盤</a:t>
-            </a:r>
-            <a:r>
-              <a:rPr sz="1500">
-                <a:solidFill>
-                  <a:srgbClr val="323130"/>
-                </a:solidFill>
-                <a:latin typeface="Meiryo"/>
-                <a:ea typeface="Meiryo"/>
-              </a:rPr>
-              <a:t> Microsoft Foundry（フォールバック）</a:t>
-            </a:r>
-          </a:p>
-          <a:p>
-            <a:pPr>
-              <a:spcAft>
-                <a:spcPts val="300"/>
-              </a:spcAft>
-            </a:pPr>
-            <a:r>
-              <a:rPr sz="1500">
-                <a:solidFill>
-                  <a:srgbClr val="323130"/>
-                </a:solidFill>
-                <a:latin typeface="Meiryo"/>
-                <a:ea typeface="Meiryo"/>
-              </a:rPr>
-              <a:t>• </a:t>
-            </a:r>
-            <a:r>
-              <a:rPr sz="1500" b="1">
-                <a:solidFill>
-                  <a:srgbClr val="323130"/>
-                </a:solidFill>
-                <a:latin typeface="Meiryo"/>
-                <a:ea typeface="Meiryo"/>
-              </a:rPr>
-              <a:t>エージェントソフト</a:t>
-            </a:r>
-            <a:r>
-              <a:rPr sz="1500">
-                <a:solidFill>
-                  <a:srgbClr val="323130"/>
-                </a:solidFill>
-                <a:latin typeface="Meiryo"/>
-                <a:ea typeface="Meiryo"/>
-              </a:rPr>
-              <a:t> </a:t>
-            </a:r>
-            <a:r>
-              <a:rPr sz="1200" b="1">
-                <a:solidFill>
-                  <a:srgbClr val="1565C0"/>
-                </a:solidFill>
-                <a:latin typeface="Meiryo"/>
-                <a:ea typeface="Meiryo"/>
-              </a:rPr>
-              <a:t>クラウド基盤</a:t>
-            </a:r>
-            <a:r>
-              <a:rPr sz="1500">
-                <a:solidFill>
-                  <a:srgbClr val="323130"/>
-                </a:solidFill>
-                <a:latin typeface="Meiryo"/>
-                <a:ea typeface="Meiryo"/>
-              </a:rPr>
-              <a:t> 自作（Azure Agent SDK on App Service）</a:t>
-            </a:r>
-          </a:p>
-          <a:p>
-            <a:pPr>
-              <a:spcAft>
-                <a:spcPts val="300"/>
-              </a:spcAft>
-            </a:pPr>
-            <a:r>
-              <a:rPr sz="1500">
-                <a:solidFill>
-                  <a:srgbClr val="323130"/>
-                </a:solidFill>
-                <a:latin typeface="Meiryo"/>
-                <a:ea typeface="Meiryo"/>
-              </a:rPr>
-              <a:t>• </a:t>
-            </a:r>
-            <a:r>
-              <a:rPr sz="1500" b="1">
-                <a:solidFill>
-                  <a:srgbClr val="323130"/>
-                </a:solidFill>
-                <a:latin typeface="Meiryo"/>
-                <a:ea typeface="Meiryo"/>
-              </a:rPr>
-              <a:t>コンテキスト</a:t>
-            </a:r>
-            <a:r>
-              <a:rPr sz="1500">
-                <a:solidFill>
-                  <a:srgbClr val="323130"/>
-                </a:solidFill>
-                <a:latin typeface="Meiryo"/>
-                <a:ea typeface="Meiryo"/>
-              </a:rPr>
-              <a:t> </a:t>
-            </a:r>
-            <a:r>
-              <a:rPr sz="1200" b="1">
-                <a:solidFill>
-                  <a:srgbClr val="C62828"/>
-                </a:solidFill>
-                <a:latin typeface="Meiryo"/>
-                <a:ea typeface="Meiryo"/>
-              </a:rPr>
-              <a:t>SaaS</a:t>
-            </a:r>
-            <a:r>
-              <a:rPr sz="1500">
-                <a:solidFill>
-                  <a:srgbClr val="323130"/>
-                </a:solidFill>
-                <a:latin typeface="Meiryo"/>
-                <a:ea typeface="Meiryo"/>
-              </a:rPr>
-              <a:t> SharePoint内の社内ドキュメント</a:t>
-            </a:r>
-          </a:p>
-        </p:txBody>
-      </p:sp>
-      <p:sp>
-        <p:nvSpPr>
-          <p:cNvPr id="7" name="TextBox 6"/>
           <p:cNvSpPr txBox="1"/>
           <p:nvPr/>
         </p:nvSpPr>
@@ -9443,67 +8630,30 @@
           </a:p>
         </p:txBody>
       </p:sp>
-      <p:sp>
-        <p:nvSpPr>
-          <p:cNvPr id="6" name="Rectangle 5"/>
-          <p:cNvSpPr/>
-          <p:nvPr/>
-        </p:nvSpPr>
-        <p:spPr>
-          <a:xfrm>
-            <a:off x="502920" y="2620772"/>
-            <a:ext cx="11183112" cy="2217420"/>
-          </a:xfrm>
-          <a:prstGeom prst="rect">
-            <a:avLst/>
-          </a:prstGeom>
-          <a:solidFill>
-            <a:srgbClr val="F5F5F5"/>
-          </a:solidFill>
-          <a:ln>
-            <a:noFill/>
-          </a:ln>
-        </p:spPr>
-        <p:style>
-          <a:lnRef idx="1">
-            <a:schemeClr val="accent1"/>
-          </a:lnRef>
-          <a:fillRef idx="3">
-            <a:schemeClr val="accent1"/>
-          </a:fillRef>
-          <a:effectRef idx="2">
-            <a:schemeClr val="accent1"/>
-          </a:effectRef>
-          <a:fontRef idx="minor">
-            <a:schemeClr val="lt1"/>
-          </a:fontRef>
-        </p:style>
-        <p:txBody>
-          <a:bodyPr rtlCol="0" anchor="ctr" wrap="none"/>
-          <a:lstStyle/>
-          <a:p>
-            <a:pPr algn="ctr"/>
-            <a:r>
-              <a:rPr sz="1200" kern="0" spc="0">
-                <a:solidFill>
-                  <a:srgbClr val="323130"/>
-                </a:solidFill>
-                <a:latin typeface="MS Gothic"/>
-                <a:ea typeface="MS Gothic"/>
-              </a:rPr>
-              <a:t>+-----------------------+             +------------------+
-|     ローカルPC        |             |    claude.ai     |
-|                       |             |                  |
-| Claude Code（実行中） |  &lt;--TLS--&gt;  | Web / モバイルUI |
-| - ファイルシステム    |             | QRコードで即接続 |
-| - MCP サーバー        |             | スマホでも操作可 |
-| - プロジェクト設定    |             |                  |
-+-----------------------+             +------------------+
- コードはローカルに留まる！メッセージだけが流れる</a:t>
-            </a:r>
-          </a:p>
-        </p:txBody>
-      </p:sp>
+      <p:pic>
+        <p:nvPicPr>
+          <p:cNvPr id="6" name="Picture 5" descr="image.png"/>
+          <p:cNvPicPr>
+            <a:picLocks noChangeAspect="1"/>
+          </p:cNvPicPr>
+          <p:nvPr/>
+        </p:nvPicPr>
+        <p:blipFill>
+          <a:blip r:embed="rId2"/>
+          <a:stretch>
+            <a:fillRect/>
+          </a:stretch>
+        </p:blipFill>
+        <p:spPr>
+          <a:xfrm>
+            <a:off x="504444" y="2620772"/>
+            <a:ext cx="11180064" cy="2767584"/>
+          </a:xfrm>
+          <a:prstGeom prst="rect">
+            <a:avLst/>
+          </a:prstGeom>
+        </p:spPr>
+      </p:pic>
       <p:sp>
         <p:nvSpPr>
           <p:cNvPr id="7" name="TextBox 6"/>
@@ -9512,8 +8662,8 @@
         </p:nvSpPr>
         <p:spPr>
           <a:xfrm>
-            <a:off x="502920" y="4929632"/>
-            <a:ext cx="11183112" cy="1059688"/>
+            <a:off x="502920" y="5479796"/>
+            <a:ext cx="11183112" cy="509524"/>
           </a:xfrm>
           <a:prstGeom prst="rect">
             <a:avLst/>
@@ -10154,70 +9304,30 @@
           </a:p>
         </p:txBody>
       </p:sp>
-      <p:sp>
-        <p:nvSpPr>
-          <p:cNvPr id="5" name="Rectangle 4"/>
-          <p:cNvSpPr/>
-          <p:nvPr/>
-        </p:nvSpPr>
-        <p:spPr>
-          <a:xfrm>
-            <a:off x="502920" y="1577340"/>
-            <a:ext cx="11183112" cy="2628900"/>
-          </a:xfrm>
-          <a:prstGeom prst="rect">
-            <a:avLst/>
-          </a:prstGeom>
-          <a:solidFill>
-            <a:srgbClr val="F5F5F5"/>
-          </a:solidFill>
-          <a:ln>
-            <a:noFill/>
-          </a:ln>
-        </p:spPr>
-        <p:style>
-          <a:lnRef idx="1">
-            <a:schemeClr val="accent1"/>
-          </a:lnRef>
-          <a:fillRef idx="3">
-            <a:schemeClr val="accent1"/>
-          </a:fillRef>
-          <a:effectRef idx="2">
-            <a:schemeClr val="accent1"/>
-          </a:effectRef>
-          <a:fontRef idx="minor">
-            <a:schemeClr val="lt1"/>
-          </a:fontRef>
-        </p:style>
-        <p:txBody>
-          <a:bodyPr rtlCol="0" anchor="ctr" wrap="none"/>
-          <a:lstStyle/>
-          <a:p>
-            <a:pPr algn="ctr"/>
-            <a:r>
-              <a:rPr sz="1100" kern="0" spc="0">
-                <a:solidFill>
-                  <a:srgbClr val="323130"/>
-                </a:solidFill>
-                <a:latin typeface="MS Gothic"/>
-                <a:ea typeface="MS Gothic"/>
-              </a:rPr>
-              <a:t>PC Terminal:
-  claude --remote "認証バグを修正して"
-        ↓
-+-------------------------------+
-| Anthropic 管理クラウドVM      |
-| - GitHub リポジトリをクローン |
-| - テスト実行・コード修正      |
-| - PR 作成まで自律実行         |
-+-------------------------------+
-        ↓
-  claude --teleport  ← ローカルに持ち帰り可能
-  （会話履歴 + ブランチごと）</a:t>
-            </a:r>
-          </a:p>
-        </p:txBody>
-      </p:sp>
+      <p:pic>
+        <p:nvPicPr>
+          <p:cNvPr id="5" name="Picture 4" descr="image.png"/>
+          <p:cNvPicPr>
+            <a:picLocks noChangeAspect="1"/>
+          </p:cNvPicPr>
+          <p:nvPr/>
+        </p:nvPicPr>
+        <p:blipFill>
+          <a:blip r:embed="rId2"/>
+          <a:stretch>
+            <a:fillRect/>
+          </a:stretch>
+        </p:blipFill>
+        <p:spPr>
+          <a:xfrm>
+            <a:off x="504444" y="1577340"/>
+            <a:ext cx="11180064" cy="3608832"/>
+          </a:xfrm>
+          <a:prstGeom prst="rect">
+            <a:avLst/>
+          </a:prstGeom>
+        </p:spPr>
+      </p:pic>
       <p:sp>
         <p:nvSpPr>
           <p:cNvPr id="6" name="TextBox 5"/>
@@ -10226,8 +9336,8 @@
         </p:nvSpPr>
         <p:spPr>
           <a:xfrm>
-            <a:off x="502920" y="4297679"/>
-            <a:ext cx="11183112" cy="1691640"/>
+            <a:off x="502920" y="5277612"/>
+            <a:ext cx="11183112" cy="711708"/>
           </a:xfrm>
           <a:prstGeom prst="rect">
             <a:avLst/>
@@ -17002,70 +16112,30 @@
           </a:p>
         </p:txBody>
       </p:sp>
-      <p:sp>
-        <p:nvSpPr>
-          <p:cNvPr id="5" name="Rectangle 4"/>
-          <p:cNvSpPr/>
-          <p:nvPr/>
-        </p:nvSpPr>
-        <p:spPr>
-          <a:xfrm>
-            <a:off x="502920" y="1577340"/>
-            <a:ext cx="11183112" cy="3863340"/>
-          </a:xfrm>
-          <a:prstGeom prst="rect">
-            <a:avLst/>
-          </a:prstGeom>
-          <a:solidFill>
-            <a:srgbClr val="F5F5F5"/>
-          </a:solidFill>
-          <a:ln>
-            <a:noFill/>
-          </a:ln>
-        </p:spPr>
-        <p:style>
-          <a:lnRef idx="1">
-            <a:schemeClr val="accent1"/>
-          </a:lnRef>
-          <a:fillRef idx="3">
-            <a:schemeClr val="accent1"/>
-          </a:fillRef>
-          <a:effectRef idx="2">
-            <a:schemeClr val="accent1"/>
-          </a:effectRef>
-          <a:fontRef idx="minor">
-            <a:schemeClr val="lt1"/>
-          </a:fontRef>
-        </p:style>
-        <p:txBody>
-          <a:bodyPr rtlCol="0" anchor="ctr" wrap="none"/>
-          <a:lstStyle/>
-          <a:p>
-            <a:pPr algn="ctr"/>
-            <a:r>
-              <a:rPr sz="1700" kern="0" spc="0">
-                <a:solidFill>
-                  <a:srgbClr val="323130"/>
-                </a:solidFill>
-                <a:latin typeface="MS Gothic"/>
-                <a:ea typeface="MS Gothic"/>
-              </a:rPr>
-              <a:t>AIエージェント（Claude Code / Cursor / Copilot...）
-              | 同じ API + 同じ RBAC
-+-------------------------------------+
-|       Azure Resource Manager        |
-|     (API + RBAC + Azure Policy)     |
-+------------------+------------------+
-| Azure (クラウド) |  オンプレミス    |
-|  - VMs           |  - Azure Local   |
-|  - AKS           |  - Arc Servers   |
-|  - Databases     |  - AKS Arc       |
-|  - Functions     |  - Arc Data Svc  |
-+------------------+------------------+</a:t>
-            </a:r>
-          </a:p>
-        </p:txBody>
-      </p:sp>
+      <p:pic>
+        <p:nvPicPr>
+          <p:cNvPr id="5" name="Picture 4" descr="image.png"/>
+          <p:cNvPicPr>
+            <a:picLocks noChangeAspect="1"/>
+          </p:cNvPicPr>
+          <p:nvPr/>
+        </p:nvPicPr>
+        <p:blipFill>
+          <a:blip r:embed="rId2"/>
+          <a:stretch>
+            <a:fillRect/>
+          </a:stretch>
+        </p:blipFill>
+        <p:spPr>
+          <a:xfrm>
+            <a:off x="504444" y="1577340"/>
+            <a:ext cx="11180064" cy="3608832"/>
+          </a:xfrm>
+          <a:prstGeom prst="rect">
+            <a:avLst/>
+          </a:prstGeom>
+        </p:spPr>
+      </p:pic>
       <p:sp>
         <p:nvSpPr>
           <p:cNvPr id="6" name="TextBox 5"/>
@@ -17074,8 +16144,8 @@
         </p:nvSpPr>
         <p:spPr>
           <a:xfrm>
-            <a:off x="502920" y="5532120"/>
-            <a:ext cx="11183112" cy="457199"/>
+            <a:off x="502920" y="5277612"/>
+            <a:ext cx="11183112" cy="711708"/>
           </a:xfrm>
           <a:prstGeom prst="rect">
             <a:avLst/>

</xml_diff>

<commit_message>
fix: reserve space for text after ASCII art images
_content_height now matches _render_ascii_art sizing for arch blocks.
Group placement loop reserves space for subsequent groups when placing
arch code images, preventing them from consuming all available space
and dropping bullet text.
</commit_message>
<xml_diff>
--- a/HCCJP_71/AI時代の「本当の」ハイブリッドクラウド — エージェントが実現した、あの頃の夢.pptx
+++ b/HCCJP_71/AI時代の「本当の」ハイブリッドクラウド — エージェントが実現した、あの頃の夢.pptx
@@ -6222,7 +6222,7 @@
         <p:spPr>
           <a:xfrm>
             <a:off x="504444" y="1577340"/>
-            <a:ext cx="11180064" cy="2767584"/>
+            <a:ext cx="11180064" cy="2205990"/>
           </a:xfrm>
           <a:prstGeom prst="rect">
             <a:avLst/>
@@ -6237,8 +6237,8 @@
         </p:nvSpPr>
         <p:spPr>
           <a:xfrm>
-            <a:off x="502920" y="4436364"/>
-            <a:ext cx="11183112" cy="1552956"/>
+            <a:off x="502920" y="3874770"/>
+            <a:ext cx="11183112" cy="2114550"/>
           </a:xfrm>
           <a:prstGeom prst="rect">
             <a:avLst/>
@@ -6597,7 +6597,7 @@
         <p:spPr>
           <a:xfrm>
             <a:off x="504444" y="1577340"/>
-            <a:ext cx="11180064" cy="4169663"/>
+            <a:ext cx="11180064" cy="3497580"/>
           </a:xfrm>
           <a:prstGeom prst="rect">
             <a:avLst/>
@@ -6607,6 +6607,183 @@
       <p:sp>
         <p:nvSpPr>
           <p:cNvPr id="6" name="TextBox 5"/>
+          <p:cNvSpPr txBox="1"/>
+          <p:nvPr/>
+        </p:nvSpPr>
+        <p:spPr>
+          <a:xfrm>
+            <a:off x="502920" y="5166360"/>
+            <a:ext cx="11183112" cy="822959"/>
+          </a:xfrm>
+          <a:prstGeom prst="rect">
+            <a:avLst/>
+          </a:prstGeom>
+          <a:noFill/>
+        </p:spPr>
+        <p:txBody>
+          <a:bodyPr wrap="square">
+            <a:normAutofit/>
+          </a:bodyPr>
+          <a:lstStyle/>
+          <a:p>
+            <a:pPr>
+              <a:spcAft>
+                <a:spcPts val="300"/>
+              </a:spcAft>
+            </a:pPr>
+            <a:r>
+              <a:rPr sz="1400">
+                <a:solidFill>
+                  <a:srgbClr val="323130"/>
+                </a:solidFill>
+                <a:latin typeface="Meiryo"/>
+                <a:ea typeface="Meiryo"/>
+              </a:rPr>
+              <a:t>• </a:t>
+            </a:r>
+            <a:r>
+              <a:rPr sz="1400" b="1">
+                <a:solidFill>
+                  <a:srgbClr val="323130"/>
+                </a:solidFill>
+                <a:latin typeface="Meiryo"/>
+                <a:ea typeface="Meiryo"/>
+              </a:rPr>
+              <a:t>モデル</a:t>
+            </a:r>
+            <a:r>
+              <a:rPr sz="1400">
+                <a:solidFill>
+                  <a:srgbClr val="323130"/>
+                </a:solidFill>
+                <a:latin typeface="Meiryo"/>
+                <a:ea typeface="Meiryo"/>
+              </a:rPr>
+              <a:t> </a:t>
+            </a:r>
+            <a:r>
+              <a:rPr sz="1100" b="1">
+                <a:solidFill>
+                  <a:srgbClr val="1565C0"/>
+                </a:solidFill>
+                <a:latin typeface="Meiryo"/>
+                <a:ea typeface="Meiryo"/>
+              </a:rPr>
+              <a:t>クラウド基盤</a:t>
+            </a:r>
+            <a:r>
+              <a:rPr sz="1400">
+                <a:solidFill>
+                  <a:srgbClr val="323130"/>
+                </a:solidFill>
+                <a:latin typeface="Meiryo"/>
+                <a:ea typeface="Meiryo"/>
+              </a:rPr>
+              <a:t> / </a:t>
+            </a:r>
+            <a:r>
+              <a:rPr sz="1400" b="1">
+                <a:solidFill>
+                  <a:srgbClr val="323130"/>
+                </a:solidFill>
+                <a:latin typeface="Meiryo"/>
+                <a:ea typeface="Meiryo"/>
+              </a:rPr>
+              <a:t>エージェントソフト</a:t>
+            </a:r>
+            <a:r>
+              <a:rPr sz="1400">
+                <a:solidFill>
+                  <a:srgbClr val="323130"/>
+                </a:solidFill>
+                <a:latin typeface="Meiryo"/>
+                <a:ea typeface="Meiryo"/>
+              </a:rPr>
+              <a:t> </a:t>
+            </a:r>
+            <a:r>
+              <a:rPr sz="1100" b="1">
+                <a:solidFill>
+                  <a:srgbClr val="1565C0"/>
+                </a:solidFill>
+                <a:latin typeface="Meiryo"/>
+                <a:ea typeface="Meiryo"/>
+              </a:rPr>
+              <a:t>クラウド基盤</a:t>
+            </a:r>
+            <a:r>
+              <a:rPr sz="1400">
+                <a:solidFill>
+                  <a:srgbClr val="323130"/>
+                </a:solidFill>
+                <a:latin typeface="Meiryo"/>
+                <a:ea typeface="Meiryo"/>
+              </a:rPr>
+              <a:t> / </a:t>
+            </a:r>
+            <a:r>
+              <a:rPr sz="1400" b="1">
+                <a:solidFill>
+                  <a:srgbClr val="323130"/>
+                </a:solidFill>
+                <a:latin typeface="Meiryo"/>
+                <a:ea typeface="Meiryo"/>
+              </a:rPr>
+              <a:t>コンテキスト</a:t>
+            </a:r>
+            <a:r>
+              <a:rPr sz="1400">
+                <a:solidFill>
+                  <a:srgbClr val="323130"/>
+                </a:solidFill>
+                <a:latin typeface="Meiryo"/>
+                <a:ea typeface="Meiryo"/>
+              </a:rPr>
+              <a:t> </a:t>
+            </a:r>
+            <a:r>
+              <a:rPr sz="1100" b="1">
+                <a:solidFill>
+                  <a:srgbClr val="1565C0"/>
+                </a:solidFill>
+                <a:latin typeface="Meiryo"/>
+                <a:ea typeface="Meiryo"/>
+              </a:rPr>
+              <a:t>クラウド基盤</a:t>
+            </a:r>
+          </a:p>
+          <a:p>
+            <a:pPr>
+              <a:spcAft>
+                <a:spcPts val="300"/>
+              </a:spcAft>
+            </a:pPr>
+            <a:r>
+              <a:rPr sz="1400">
+                <a:solidFill>
+                  <a:srgbClr val="323130"/>
+                </a:solidFill>
+                <a:latin typeface="Meiryo"/>
+                <a:ea typeface="Meiryo"/>
+              </a:rPr>
+              <a:t>• → </a:t>
+            </a:r>
+            <a:r>
+              <a:rPr sz="1400" b="1">
+                <a:solidFill>
+                  <a:srgbClr val="323130"/>
+                </a:solidFill>
+                <a:latin typeface="Meiryo"/>
+                <a:ea typeface="Meiryo"/>
+              </a:rPr>
+              <a:t>すべてクラウド基盤。自前で構築・管理する典型的なエンタープライズ構成</a:t>
+            </a:r>
+          </a:p>
+        </p:txBody>
+      </p:sp>
+      <p:sp>
+        <p:nvSpPr>
+          <p:cNvPr id="7" name="TextBox 6"/>
           <p:cNvSpPr txBox="1"/>
           <p:nvPr/>
         </p:nvSpPr>
@@ -6795,7 +6972,7 @@
         <p:spPr>
           <a:xfrm>
             <a:off x="504444" y="1577340"/>
-            <a:ext cx="11180064" cy="4169663"/>
+            <a:ext cx="11180064" cy="3497580"/>
           </a:xfrm>
           <a:prstGeom prst="rect">
             <a:avLst/>
@@ -6805,6 +6982,183 @@
       <p:sp>
         <p:nvSpPr>
           <p:cNvPr id="6" name="TextBox 5"/>
+          <p:cNvSpPr txBox="1"/>
+          <p:nvPr/>
+        </p:nvSpPr>
+        <p:spPr>
+          <a:xfrm>
+            <a:off x="502920" y="5166360"/>
+            <a:ext cx="11183112" cy="822959"/>
+          </a:xfrm>
+          <a:prstGeom prst="rect">
+            <a:avLst/>
+          </a:prstGeom>
+          <a:noFill/>
+        </p:spPr>
+        <p:txBody>
+          <a:bodyPr wrap="square">
+            <a:normAutofit/>
+          </a:bodyPr>
+          <a:lstStyle/>
+          <a:p>
+            <a:pPr>
+              <a:spcAft>
+                <a:spcPts val="300"/>
+              </a:spcAft>
+            </a:pPr>
+            <a:r>
+              <a:rPr sz="1400">
+                <a:solidFill>
+                  <a:srgbClr val="323130"/>
+                </a:solidFill>
+                <a:latin typeface="Meiryo"/>
+                <a:ea typeface="Meiryo"/>
+              </a:rPr>
+              <a:t>• </a:t>
+            </a:r>
+            <a:r>
+              <a:rPr sz="1400" b="1">
+                <a:solidFill>
+                  <a:srgbClr val="323130"/>
+                </a:solidFill>
+                <a:latin typeface="Meiryo"/>
+                <a:ea typeface="Meiryo"/>
+              </a:rPr>
+              <a:t>モデル</a:t>
+            </a:r>
+            <a:r>
+              <a:rPr sz="1400">
+                <a:solidFill>
+                  <a:srgbClr val="323130"/>
+                </a:solidFill>
+                <a:latin typeface="Meiryo"/>
+                <a:ea typeface="Meiryo"/>
+              </a:rPr>
+              <a:t> </a:t>
+            </a:r>
+            <a:r>
+              <a:rPr sz="1100" b="1">
+                <a:solidFill>
+                  <a:srgbClr val="2E7D32"/>
+                </a:solidFill>
+                <a:latin typeface="Meiryo"/>
+                <a:ea typeface="Meiryo"/>
+              </a:rPr>
+              <a:t>オンプレ</a:t>
+            </a:r>
+            <a:r>
+              <a:rPr sz="1400">
+                <a:solidFill>
+                  <a:srgbClr val="323130"/>
+                </a:solidFill>
+                <a:latin typeface="Meiryo"/>
+                <a:ea typeface="Meiryo"/>
+              </a:rPr>
+              <a:t> / </a:t>
+            </a:r>
+            <a:r>
+              <a:rPr sz="1400" b="1">
+                <a:solidFill>
+                  <a:srgbClr val="323130"/>
+                </a:solidFill>
+                <a:latin typeface="Meiryo"/>
+                <a:ea typeface="Meiryo"/>
+              </a:rPr>
+              <a:t>エージェントソフト</a:t>
+            </a:r>
+            <a:r>
+              <a:rPr sz="1400">
+                <a:solidFill>
+                  <a:srgbClr val="323130"/>
+                </a:solidFill>
+                <a:latin typeface="Meiryo"/>
+                <a:ea typeface="Meiryo"/>
+              </a:rPr>
+              <a:t> </a:t>
+            </a:r>
+            <a:r>
+              <a:rPr sz="1100" b="1">
+                <a:solidFill>
+                  <a:srgbClr val="2E7D32"/>
+                </a:solidFill>
+                <a:latin typeface="Meiryo"/>
+                <a:ea typeface="Meiryo"/>
+              </a:rPr>
+              <a:t>オンプレ</a:t>
+            </a:r>
+            <a:r>
+              <a:rPr sz="1400">
+                <a:solidFill>
+                  <a:srgbClr val="323130"/>
+                </a:solidFill>
+                <a:latin typeface="Meiryo"/>
+                <a:ea typeface="Meiryo"/>
+              </a:rPr>
+              <a:t> / </a:t>
+            </a:r>
+            <a:r>
+              <a:rPr sz="1400" b="1">
+                <a:solidFill>
+                  <a:srgbClr val="323130"/>
+                </a:solidFill>
+                <a:latin typeface="Meiryo"/>
+                <a:ea typeface="Meiryo"/>
+              </a:rPr>
+              <a:t>コンテキスト</a:t>
+            </a:r>
+            <a:r>
+              <a:rPr sz="1400">
+                <a:solidFill>
+                  <a:srgbClr val="323130"/>
+                </a:solidFill>
+                <a:latin typeface="Meiryo"/>
+                <a:ea typeface="Meiryo"/>
+              </a:rPr>
+              <a:t> </a:t>
+            </a:r>
+            <a:r>
+              <a:rPr sz="1100" b="1">
+                <a:solidFill>
+                  <a:srgbClr val="2E7D32"/>
+                </a:solidFill>
+                <a:latin typeface="Meiryo"/>
+                <a:ea typeface="Meiryo"/>
+              </a:rPr>
+              <a:t>オンプレ</a:t>
+            </a:r>
+          </a:p>
+          <a:p>
+            <a:pPr>
+              <a:spcAft>
+                <a:spcPts val="300"/>
+              </a:spcAft>
+            </a:pPr>
+            <a:r>
+              <a:rPr sz="1400">
+                <a:solidFill>
+                  <a:srgbClr val="323130"/>
+                </a:solidFill>
+                <a:latin typeface="Meiryo"/>
+                <a:ea typeface="Meiryo"/>
+              </a:rPr>
+              <a:t>• → </a:t>
+            </a:r>
+            <a:r>
+              <a:rPr sz="1400" b="1">
+                <a:solidFill>
+                  <a:srgbClr val="323130"/>
+                </a:solidFill>
+                <a:latin typeface="Meiryo"/>
+                <a:ea typeface="Meiryo"/>
+              </a:rPr>
+              <a:t>すべてオンプレ。データを外に出せない要件がある場合の構成</a:t>
+            </a:r>
+          </a:p>
+        </p:txBody>
+      </p:sp>
+      <p:sp>
+        <p:nvSpPr>
+          <p:cNvPr id="7" name="TextBox 6"/>
           <p:cNvSpPr txBox="1"/>
           <p:nvPr/>
         </p:nvSpPr>
@@ -6993,7 +7347,7 @@
         <p:spPr>
           <a:xfrm>
             <a:off x="504444" y="1577340"/>
-            <a:ext cx="11180064" cy="3608832"/>
+            <a:ext cx="11180064" cy="3169920"/>
           </a:xfrm>
           <a:prstGeom prst="rect">
             <a:avLst/>
@@ -7008,8 +7362,8 @@
         </p:nvSpPr>
         <p:spPr>
           <a:xfrm>
-            <a:off x="502920" y="5277612"/>
-            <a:ext cx="11183112" cy="711708"/>
+            <a:off x="502920" y="4838699"/>
+            <a:ext cx="11183112" cy="1150620"/>
           </a:xfrm>
           <a:prstGeom prst="rect">
             <a:avLst/>
@@ -7024,11 +7378,11 @@
           <a:p>
             <a:pPr>
               <a:spcAft>
-                <a:spcPts val="500"/>
+                <a:spcPts val="300"/>
               </a:spcAft>
             </a:pPr>
             <a:r>
-              <a:rPr sz="2100">
+              <a:rPr sz="1400">
                 <a:solidFill>
                   <a:srgbClr val="323130"/>
                 </a:solidFill>
@@ -7038,7 +7392,7 @@
               <a:t>• </a:t>
             </a:r>
             <a:r>
-              <a:rPr sz="2100" b="1">
+              <a:rPr sz="1400" b="1">
                 <a:solidFill>
                   <a:srgbClr val="323130"/>
                 </a:solidFill>
@@ -7048,7 +7402,7 @@
               <a:t>モデル</a:t>
             </a:r>
             <a:r>
-              <a:rPr sz="2100">
+              <a:rPr sz="1400">
                 <a:solidFill>
                   <a:srgbClr val="323130"/>
                 </a:solidFill>
@@ -7058,7 +7412,7 @@
               <a:t> </a:t>
             </a:r>
             <a:r>
-              <a:rPr sz="1700" b="1">
+              <a:rPr sz="1100" b="1">
                 <a:solidFill>
                   <a:srgbClr val="C62828"/>
                 </a:solidFill>
@@ -7068,7 +7422,7 @@
               <a:t>SaaS</a:t>
             </a:r>
             <a:r>
-              <a:rPr sz="2100">
+              <a:rPr sz="1400">
                 <a:solidFill>
                   <a:srgbClr val="323130"/>
                 </a:solidFill>
@@ -7081,11 +7435,11 @@
           <a:p>
             <a:pPr>
               <a:spcAft>
-                <a:spcPts val="500"/>
+                <a:spcPts val="300"/>
               </a:spcAft>
             </a:pPr>
             <a:r>
-              <a:rPr sz="2100">
+              <a:rPr sz="1400">
                 <a:solidFill>
                   <a:srgbClr val="323130"/>
                 </a:solidFill>
@@ -7095,7 +7449,7 @@
               <a:t>• </a:t>
             </a:r>
             <a:r>
-              <a:rPr sz="2100" b="1">
+              <a:rPr sz="1400" b="1">
                 <a:solidFill>
                   <a:srgbClr val="323130"/>
                 </a:solidFill>
@@ -7105,7 +7459,7 @@
               <a:t>エージェントソフト</a:t>
             </a:r>
             <a:r>
-              <a:rPr sz="2100">
+              <a:rPr sz="1400">
                 <a:solidFill>
                   <a:srgbClr val="323130"/>
                 </a:solidFill>
@@ -7115,7 +7469,7 @@
               <a:t> </a:t>
             </a:r>
             <a:r>
-              <a:rPr sz="1700" b="1">
+              <a:rPr sz="1100" b="1">
                 <a:solidFill>
                   <a:srgbClr val="2E7D32"/>
                 </a:solidFill>
@@ -7125,7 +7479,7 @@
               <a:t>オンプレ</a:t>
             </a:r>
             <a:r>
-              <a:rPr sz="2100">
+              <a:rPr sz="1400">
                 <a:solidFill>
                   <a:srgbClr val="323130"/>
                 </a:solidFill>
@@ -7138,11 +7492,11 @@
           <a:p>
             <a:pPr>
               <a:spcAft>
-                <a:spcPts val="500"/>
+                <a:spcPts val="300"/>
               </a:spcAft>
             </a:pPr>
             <a:r>
-              <a:rPr sz="2100">
+              <a:rPr sz="1400">
                 <a:solidFill>
                   <a:srgbClr val="323130"/>
                 </a:solidFill>
@@ -7152,7 +7506,7 @@
               <a:t>• </a:t>
             </a:r>
             <a:r>
-              <a:rPr sz="2100" b="1">
+              <a:rPr sz="1400" b="1">
                 <a:solidFill>
                   <a:srgbClr val="323130"/>
                 </a:solidFill>
@@ -7162,7 +7516,7 @@
               <a:t>コンテキスト</a:t>
             </a:r>
             <a:r>
-              <a:rPr sz="2100">
+              <a:rPr sz="1400">
                 <a:solidFill>
                   <a:srgbClr val="323130"/>
                 </a:solidFill>
@@ -7172,7 +7526,7 @@
               <a:t> </a:t>
             </a:r>
             <a:r>
-              <a:rPr sz="1700" b="1">
+              <a:rPr sz="1100" b="1">
                 <a:solidFill>
                   <a:srgbClr val="2E7D32"/>
                 </a:solidFill>
@@ -7182,7 +7536,7 @@
               <a:t>オンプレ</a:t>
             </a:r>
             <a:r>
-              <a:rPr sz="2100">
+              <a:rPr sz="1400">
                 <a:solidFill>
                   <a:srgbClr val="323130"/>
                 </a:solidFill>
@@ -7192,7 +7546,7 @@
               <a:t> ソースコード等 + </a:t>
             </a:r>
             <a:r>
-              <a:rPr sz="1700" b="1">
+              <a:rPr sz="1100" b="1">
                 <a:solidFill>
                   <a:srgbClr val="C62828"/>
                 </a:solidFill>
@@ -7202,7 +7556,7 @@
               <a:t>SaaS</a:t>
             </a:r>
             <a:r>
-              <a:rPr sz="2100">
+              <a:rPr sz="1400">
                 <a:solidFill>
                   <a:srgbClr val="323130"/>
                 </a:solidFill>
@@ -7405,7 +7759,7 @@
         <p:spPr>
           <a:xfrm>
             <a:off x="504444" y="1577340"/>
-            <a:ext cx="11180064" cy="3889247"/>
+            <a:ext cx="11180064" cy="2859024"/>
           </a:xfrm>
           <a:prstGeom prst="rect">
             <a:avLst/>
@@ -7420,8 +7774,8 @@
         </p:nvSpPr>
         <p:spPr>
           <a:xfrm>
-            <a:off x="502920" y="5558028"/>
-            <a:ext cx="11183112" cy="431292"/>
+            <a:off x="502920" y="4527804"/>
+            <a:ext cx="11183112" cy="1461516"/>
           </a:xfrm>
           <a:prstGeom prst="rect">
             <a:avLst/>
@@ -7436,11 +7790,11 @@
           <a:p>
             <a:pPr>
               <a:spcAft>
-                <a:spcPts val="400"/>
+                <a:spcPts val="300"/>
               </a:spcAft>
             </a:pPr>
             <a:r>
-              <a:rPr sz="1800">
+              <a:rPr sz="1400">
                 <a:solidFill>
                   <a:srgbClr val="323130"/>
                 </a:solidFill>
@@ -7450,7 +7804,7 @@
               <a:t>• </a:t>
             </a:r>
             <a:r>
-              <a:rPr sz="1800" b="1">
+              <a:rPr sz="1400" b="1">
                 <a:solidFill>
                   <a:srgbClr val="323130"/>
                 </a:solidFill>
@@ -7460,7 +7814,7 @@
               <a:t>モデル</a:t>
             </a:r>
             <a:r>
-              <a:rPr sz="1800">
+              <a:rPr sz="1400">
                 <a:solidFill>
                   <a:srgbClr val="323130"/>
                 </a:solidFill>
@@ -7470,7 +7824,7 @@
               <a:t> </a:t>
             </a:r>
             <a:r>
-              <a:rPr sz="1500" b="1">
+              <a:rPr sz="1100" b="1">
                 <a:solidFill>
                   <a:srgbClr val="C62828"/>
                 </a:solidFill>
@@ -7480,7 +7834,7 @@
               <a:t>SaaS</a:t>
             </a:r>
             <a:r>
-              <a:rPr sz="1800">
+              <a:rPr sz="1400">
                 <a:solidFill>
                   <a:srgbClr val="323130"/>
                 </a:solidFill>
@@ -7493,11 +7847,11 @@
           <a:p>
             <a:pPr>
               <a:spcAft>
-                <a:spcPts val="400"/>
+                <a:spcPts val="300"/>
               </a:spcAft>
             </a:pPr>
             <a:r>
-              <a:rPr sz="1800">
+              <a:rPr sz="1400">
                 <a:solidFill>
                   <a:srgbClr val="323130"/>
                 </a:solidFill>
@@ -7507,7 +7861,7 @@
               <a:t>• </a:t>
             </a:r>
             <a:r>
-              <a:rPr sz="1800" b="1">
+              <a:rPr sz="1400" b="1">
                 <a:solidFill>
                   <a:srgbClr val="323130"/>
                 </a:solidFill>
@@ -7517,7 +7871,7 @@
               <a:t>エージェントソフト</a:t>
             </a:r>
             <a:r>
-              <a:rPr sz="1800">
+              <a:rPr sz="1400">
                 <a:solidFill>
                   <a:srgbClr val="323130"/>
                 </a:solidFill>
@@ -7527,7 +7881,7 @@
               <a:t> </a:t>
             </a:r>
             <a:r>
-              <a:rPr sz="1500" b="1">
+              <a:rPr sz="1100" b="1">
                 <a:solidFill>
                   <a:srgbClr val="2E7D32"/>
                 </a:solidFill>
@@ -7537,7 +7891,7 @@
               <a:t>オンプレ</a:t>
             </a:r>
             <a:r>
-              <a:rPr sz="1800">
+              <a:rPr sz="1400">
                 <a:solidFill>
                   <a:srgbClr val="323130"/>
                 </a:solidFill>
@@ -7550,11 +7904,11 @@
           <a:p>
             <a:pPr>
               <a:spcAft>
-                <a:spcPts val="400"/>
+                <a:spcPts val="300"/>
               </a:spcAft>
             </a:pPr>
             <a:r>
-              <a:rPr sz="1800">
+              <a:rPr sz="1400">
                 <a:solidFill>
                   <a:srgbClr val="323130"/>
                 </a:solidFill>
@@ -7564,7 +7918,7 @@
               <a:t>• </a:t>
             </a:r>
             <a:r>
-              <a:rPr sz="1800" b="1">
+              <a:rPr sz="1400" b="1">
                 <a:solidFill>
                   <a:srgbClr val="323130"/>
                 </a:solidFill>
@@ -7574,7 +7928,7 @@
               <a:t>コンテキスト</a:t>
             </a:r>
             <a:r>
-              <a:rPr sz="1800">
+              <a:rPr sz="1400">
                 <a:solidFill>
                   <a:srgbClr val="323130"/>
                 </a:solidFill>
@@ -7584,7 +7938,7 @@
               <a:t> </a:t>
             </a:r>
             <a:r>
-              <a:rPr sz="1500" b="1">
+              <a:rPr sz="1100" b="1">
                 <a:solidFill>
                   <a:srgbClr val="2E7D32"/>
                 </a:solidFill>
@@ -7594,7 +7948,7 @@
               <a:t>オンプレ</a:t>
             </a:r>
             <a:r>
-              <a:rPr sz="1800">
+              <a:rPr sz="1400">
                 <a:solidFill>
                   <a:srgbClr val="323130"/>
                 </a:solidFill>
@@ -7604,7 +7958,7 @@
               <a:t> CLAUDE.md, Obsidian等 + </a:t>
             </a:r>
             <a:r>
-              <a:rPr sz="1500" b="1">
+              <a:rPr sz="1100" b="1">
                 <a:solidFill>
                   <a:srgbClr val="C62828"/>
                 </a:solidFill>
@@ -7614,7 +7968,7 @@
               <a:t>SaaS</a:t>
             </a:r>
             <a:r>
-              <a:rPr sz="1800">
+              <a:rPr sz="1400">
                 <a:solidFill>
                   <a:srgbClr val="323130"/>
                 </a:solidFill>
@@ -7627,11 +7981,11 @@
           <a:p>
             <a:pPr>
               <a:spcAft>
-                <a:spcPts val="400"/>
+                <a:spcPts val="300"/>
               </a:spcAft>
             </a:pPr>
             <a:r>
-              <a:rPr sz="1800">
+              <a:rPr sz="1400">
                 <a:solidFill>
                   <a:srgbClr val="323130"/>
                 </a:solidFill>
@@ -7834,7 +8188,7 @@
         <p:spPr>
           <a:xfrm>
             <a:off x="504444" y="2194560"/>
-            <a:ext cx="11180064" cy="3794759"/>
+            <a:ext cx="11180064" cy="2578099"/>
           </a:xfrm>
           <a:prstGeom prst="rect">
             <a:avLst/>
@@ -7844,6 +8198,220 @@
       <p:sp>
         <p:nvSpPr>
           <p:cNvPr id="6" name="TextBox 5"/>
+          <p:cNvSpPr txBox="1"/>
+          <p:nvPr/>
+        </p:nvSpPr>
+        <p:spPr>
+          <a:xfrm>
+            <a:off x="502920" y="4864099"/>
+            <a:ext cx="11183112" cy="1125220"/>
+          </a:xfrm>
+          <a:prstGeom prst="rect">
+            <a:avLst/>
+          </a:prstGeom>
+          <a:noFill/>
+        </p:spPr>
+        <p:txBody>
+          <a:bodyPr wrap="square">
+            <a:normAutofit/>
+          </a:bodyPr>
+          <a:lstStyle/>
+          <a:p>
+            <a:pPr>
+              <a:spcAft>
+                <a:spcPts val="300"/>
+              </a:spcAft>
+            </a:pPr>
+            <a:r>
+              <a:rPr sz="1400">
+                <a:solidFill>
+                  <a:srgbClr val="323130"/>
+                </a:solidFill>
+                <a:latin typeface="Meiryo"/>
+                <a:ea typeface="Meiryo"/>
+              </a:rPr>
+              <a:t>• </a:t>
+            </a:r>
+            <a:r>
+              <a:rPr sz="1400" b="1">
+                <a:solidFill>
+                  <a:srgbClr val="323130"/>
+                </a:solidFill>
+                <a:latin typeface="Meiryo"/>
+                <a:ea typeface="Meiryo"/>
+              </a:rPr>
+              <a:t>モデル</a:t>
+            </a:r>
+            <a:r>
+              <a:rPr sz="1400">
+                <a:solidFill>
+                  <a:srgbClr val="323130"/>
+                </a:solidFill>
+                <a:latin typeface="Meiryo"/>
+                <a:ea typeface="Meiryo"/>
+              </a:rPr>
+              <a:t> </a:t>
+            </a:r>
+            <a:r>
+              <a:rPr sz="1100" b="1">
+                <a:solidFill>
+                  <a:srgbClr val="2E7D32"/>
+                </a:solidFill>
+                <a:latin typeface="Meiryo"/>
+                <a:ea typeface="Meiryo"/>
+              </a:rPr>
+              <a:t>オンプレ</a:t>
+            </a:r>
+            <a:r>
+              <a:rPr sz="1400">
+                <a:solidFill>
+                  <a:srgbClr val="323130"/>
+                </a:solidFill>
+                <a:latin typeface="Meiryo"/>
+                <a:ea typeface="Meiryo"/>
+              </a:rPr>
+              <a:t> DGX Spark + </a:t>
+            </a:r>
+            <a:r>
+              <a:rPr sz="1100" b="1">
+                <a:solidFill>
+                  <a:srgbClr val="1565C0"/>
+                </a:solidFill>
+                <a:latin typeface="Meiryo"/>
+                <a:ea typeface="Meiryo"/>
+              </a:rPr>
+              <a:t>クラウド基盤</a:t>
+            </a:r>
+            <a:r>
+              <a:rPr sz="1400">
+                <a:solidFill>
+                  <a:srgbClr val="323130"/>
+                </a:solidFill>
+                <a:latin typeface="Meiryo"/>
+                <a:ea typeface="Meiryo"/>
+              </a:rPr>
+              <a:t> Microsoft Foundry（フォールバック）</a:t>
+            </a:r>
+          </a:p>
+          <a:p>
+            <a:pPr>
+              <a:spcAft>
+                <a:spcPts val="300"/>
+              </a:spcAft>
+            </a:pPr>
+            <a:r>
+              <a:rPr sz="1400">
+                <a:solidFill>
+                  <a:srgbClr val="323130"/>
+                </a:solidFill>
+                <a:latin typeface="Meiryo"/>
+                <a:ea typeface="Meiryo"/>
+              </a:rPr>
+              <a:t>• </a:t>
+            </a:r>
+            <a:r>
+              <a:rPr sz="1400" b="1">
+                <a:solidFill>
+                  <a:srgbClr val="323130"/>
+                </a:solidFill>
+                <a:latin typeface="Meiryo"/>
+                <a:ea typeface="Meiryo"/>
+              </a:rPr>
+              <a:t>エージェントソフト</a:t>
+            </a:r>
+            <a:r>
+              <a:rPr sz="1400">
+                <a:solidFill>
+                  <a:srgbClr val="323130"/>
+                </a:solidFill>
+                <a:latin typeface="Meiryo"/>
+                <a:ea typeface="Meiryo"/>
+              </a:rPr>
+              <a:t> </a:t>
+            </a:r>
+            <a:r>
+              <a:rPr sz="1100" b="1">
+                <a:solidFill>
+                  <a:srgbClr val="1565C0"/>
+                </a:solidFill>
+                <a:latin typeface="Meiryo"/>
+                <a:ea typeface="Meiryo"/>
+              </a:rPr>
+              <a:t>クラウド基盤</a:t>
+            </a:r>
+            <a:r>
+              <a:rPr sz="1400">
+                <a:solidFill>
+                  <a:srgbClr val="323130"/>
+                </a:solidFill>
+                <a:latin typeface="Meiryo"/>
+                <a:ea typeface="Meiryo"/>
+              </a:rPr>
+              <a:t> 自作（Azure Agent SDK on App Service）</a:t>
+            </a:r>
+          </a:p>
+          <a:p>
+            <a:pPr>
+              <a:spcAft>
+                <a:spcPts val="300"/>
+              </a:spcAft>
+            </a:pPr>
+            <a:r>
+              <a:rPr sz="1400">
+                <a:solidFill>
+                  <a:srgbClr val="323130"/>
+                </a:solidFill>
+                <a:latin typeface="Meiryo"/>
+                <a:ea typeface="Meiryo"/>
+              </a:rPr>
+              <a:t>• </a:t>
+            </a:r>
+            <a:r>
+              <a:rPr sz="1400" b="1">
+                <a:solidFill>
+                  <a:srgbClr val="323130"/>
+                </a:solidFill>
+                <a:latin typeface="Meiryo"/>
+                <a:ea typeface="Meiryo"/>
+              </a:rPr>
+              <a:t>コンテキスト</a:t>
+            </a:r>
+            <a:r>
+              <a:rPr sz="1400">
+                <a:solidFill>
+                  <a:srgbClr val="323130"/>
+                </a:solidFill>
+                <a:latin typeface="Meiryo"/>
+                <a:ea typeface="Meiryo"/>
+              </a:rPr>
+              <a:t> </a:t>
+            </a:r>
+            <a:r>
+              <a:rPr sz="1100" b="1">
+                <a:solidFill>
+                  <a:srgbClr val="C62828"/>
+                </a:solidFill>
+                <a:latin typeface="Meiryo"/>
+                <a:ea typeface="Meiryo"/>
+              </a:rPr>
+              <a:t>SaaS</a:t>
+            </a:r>
+            <a:r>
+              <a:rPr sz="1400">
+                <a:solidFill>
+                  <a:srgbClr val="323130"/>
+                </a:solidFill>
+                <a:latin typeface="Meiryo"/>
+                <a:ea typeface="Meiryo"/>
+              </a:rPr>
+              <a:t> SharePoint内の社内ドキュメント</a:t>
+            </a:r>
+          </a:p>
+        </p:txBody>
+      </p:sp>
+      <p:sp>
+        <p:nvSpPr>
+          <p:cNvPr id="7" name="TextBox 6"/>
           <p:cNvSpPr txBox="1"/>
           <p:nvPr/>
         </p:nvSpPr>
@@ -8599,7 +9167,7 @@
         <p:spPr>
           <a:xfrm>
             <a:off x="502920" y="1577340"/>
-            <a:ext cx="11183112" cy="951992"/>
+            <a:ext cx="11183112" cy="823976"/>
           </a:xfrm>
           <a:prstGeom prst="rect">
             <a:avLst/>
@@ -8614,11 +9182,11 @@
           <a:p>
             <a:pPr>
               <a:spcAft>
-                <a:spcPts val="600"/>
+                <a:spcPts val="400"/>
               </a:spcAft>
             </a:pPr>
             <a:r>
-              <a:rPr sz="2000" b="1">
+              <a:rPr sz="1600" b="1">
                 <a:solidFill>
                   <a:srgbClr val="0078D4"/>
                 </a:solidFill>
@@ -8646,8 +9214,8 @@
         </p:blipFill>
         <p:spPr>
           <a:xfrm>
-            <a:off x="504444" y="2620772"/>
-            <a:ext cx="11180064" cy="2767584"/>
+            <a:off x="504444" y="2492756"/>
+            <a:ext cx="11180064" cy="1977644"/>
           </a:xfrm>
           <a:prstGeom prst="rect">
             <a:avLst/>
@@ -8662,8 +9230,8 @@
         </p:nvSpPr>
         <p:spPr>
           <a:xfrm>
-            <a:off x="502920" y="5479796"/>
-            <a:ext cx="11183112" cy="509524"/>
+            <a:off x="502920" y="4561840"/>
+            <a:ext cx="11183112" cy="1427479"/>
           </a:xfrm>
           <a:prstGeom prst="rect">
             <a:avLst/>
@@ -8678,11 +9246,11 @@
           <a:p>
             <a:pPr>
               <a:spcAft>
-                <a:spcPts val="400"/>
+                <a:spcPts val="300"/>
               </a:spcAft>
             </a:pPr>
             <a:r>
-              <a:rPr sz="1800">
+              <a:rPr sz="1400">
                 <a:solidFill>
                   <a:srgbClr val="323130"/>
                 </a:solidFill>
@@ -8692,7 +9260,7 @@
               <a:t>• </a:t>
             </a:r>
             <a:r>
-              <a:rPr sz="1500">
+              <a:rPr sz="1100">
                 <a:solidFill>
                   <a:srgbClr val="C7254E"/>
                 </a:solidFill>
@@ -8702,7 +9270,7 @@
               <a:t>claude remote-control</a:t>
             </a:r>
             <a:r>
-              <a:rPr sz="1800">
+              <a:rPr sz="1400">
                 <a:solidFill>
                   <a:srgbClr val="323130"/>
                 </a:solidFill>
@@ -8712,7 +9280,7 @@
               <a:t> または </a:t>
             </a:r>
             <a:r>
-              <a:rPr sz="1500">
+              <a:rPr sz="1100">
                 <a:solidFill>
                   <a:srgbClr val="C7254E"/>
                 </a:solidFill>
@@ -8722,7 +9290,7 @@
               <a:t>/rc</a:t>
             </a:r>
             <a:r>
-              <a:rPr sz="1800">
+              <a:rPr sz="1400">
                 <a:solidFill>
                   <a:srgbClr val="323130"/>
                 </a:solidFill>
@@ -8735,11 +9303,11 @@
           <a:p>
             <a:pPr>
               <a:spcAft>
-                <a:spcPts val="400"/>
+                <a:spcPts val="300"/>
               </a:spcAft>
             </a:pPr>
             <a:r>
-              <a:rPr sz="1800">
+              <a:rPr sz="1400">
                 <a:solidFill>
                   <a:srgbClr val="323130"/>
                 </a:solidFill>
@@ -8752,11 +9320,11 @@
           <a:p>
             <a:pPr>
               <a:spcAft>
-                <a:spcPts val="400"/>
+                <a:spcPts val="300"/>
               </a:spcAft>
             </a:pPr>
             <a:r>
-              <a:rPr sz="1800">
+              <a:rPr sz="1400">
                 <a:solidFill>
                   <a:srgbClr val="323130"/>
                 </a:solidFill>
@@ -8766,7 +9334,7 @@
               <a:t>• </a:t>
             </a:r>
             <a:r>
-              <a:rPr sz="1800" b="1">
+              <a:rPr sz="1400" b="1">
                 <a:solidFill>
                   <a:srgbClr val="323130"/>
                 </a:solidFill>
@@ -8776,7 +9344,7 @@
               <a:t>モデル</a:t>
             </a:r>
             <a:r>
-              <a:rPr sz="1800">
+              <a:rPr sz="1400">
                 <a:solidFill>
                   <a:srgbClr val="323130"/>
                 </a:solidFill>
@@ -8786,7 +9354,7 @@
               <a:t> </a:t>
             </a:r>
             <a:r>
-              <a:rPr sz="1500" b="1">
+              <a:rPr sz="1100" b="1">
                 <a:solidFill>
                   <a:srgbClr val="C62828"/>
                 </a:solidFill>
@@ -8796,7 +9364,7 @@
               <a:t>SaaS</a:t>
             </a:r>
             <a:r>
-              <a:rPr sz="1800">
+              <a:rPr sz="1400">
                 <a:solidFill>
                   <a:srgbClr val="323130"/>
                 </a:solidFill>
@@ -8806,7 +9374,7 @@
               <a:t> / </a:t>
             </a:r>
             <a:r>
-              <a:rPr sz="1800" b="1">
+              <a:rPr sz="1400" b="1">
                 <a:solidFill>
                   <a:srgbClr val="323130"/>
                 </a:solidFill>
@@ -8816,7 +9384,7 @@
               <a:t>エージェントソフト</a:t>
             </a:r>
             <a:r>
-              <a:rPr sz="1800">
+              <a:rPr sz="1400">
                 <a:solidFill>
                   <a:srgbClr val="323130"/>
                 </a:solidFill>
@@ -8826,7 +9394,7 @@
               <a:t> </a:t>
             </a:r>
             <a:r>
-              <a:rPr sz="1500" b="1">
+              <a:rPr sz="1100" b="1">
                 <a:solidFill>
                   <a:srgbClr val="2E7D32"/>
                 </a:solidFill>
@@ -8836,7 +9404,7 @@
               <a:t>オンプレ</a:t>
             </a:r>
             <a:r>
-              <a:rPr sz="1800">
+              <a:rPr sz="1400">
                 <a:solidFill>
                   <a:srgbClr val="323130"/>
                 </a:solidFill>
@@ -8846,7 +9414,7 @@
               <a:t> / </a:t>
             </a:r>
             <a:r>
-              <a:rPr sz="1800" b="1">
+              <a:rPr sz="1400" b="1">
                 <a:solidFill>
                   <a:srgbClr val="323130"/>
                 </a:solidFill>
@@ -8856,7 +9424,7 @@
               <a:t>コンテキスト</a:t>
             </a:r>
             <a:r>
-              <a:rPr sz="1800">
+              <a:rPr sz="1400">
                 <a:solidFill>
                   <a:srgbClr val="323130"/>
                 </a:solidFill>
@@ -8866,7 +9434,7 @@
               <a:t> </a:t>
             </a:r>
             <a:r>
-              <a:rPr sz="1500" b="1">
+              <a:rPr sz="1100" b="1">
                 <a:solidFill>
                   <a:srgbClr val="2E7D32"/>
                 </a:solidFill>
@@ -8879,11 +9447,11 @@
           <a:p>
             <a:pPr>
               <a:spcAft>
-                <a:spcPts val="400"/>
+                <a:spcPts val="300"/>
               </a:spcAft>
             </a:pPr>
             <a:r>
-              <a:rPr sz="1800">
+              <a:rPr sz="1400">
                 <a:solidFill>
                   <a:srgbClr val="323130"/>
                 </a:solidFill>
@@ -8893,7 +9461,7 @@
               <a:t>• </a:t>
             </a:r>
             <a:r>
-              <a:rPr sz="1800" b="1">
+              <a:rPr sz="1400" b="1">
                 <a:solidFill>
                   <a:srgbClr val="323130"/>
                 </a:solidFill>
@@ -8903,7 +9471,7 @@
               <a:t>操作UI</a:t>
             </a:r>
             <a:r>
-              <a:rPr sz="1800">
+              <a:rPr sz="1400">
                 <a:solidFill>
                   <a:srgbClr val="323130"/>
                 </a:solidFill>
@@ -8913,7 +9481,7 @@
               <a:t> </a:t>
             </a:r>
             <a:r>
-              <a:rPr sz="1500" b="1">
+              <a:rPr sz="1100" b="1">
                 <a:solidFill>
                   <a:srgbClr val="C62828"/>
                 </a:solidFill>
@@ -8923,7 +9491,7 @@
               <a:t>SaaS</a:t>
             </a:r>
             <a:r>
-              <a:rPr sz="1800">
+              <a:rPr sz="1400">
                 <a:solidFill>
                   <a:srgbClr val="323130"/>
                 </a:solidFill>
@@ -9321,7 +9889,7 @@
         <p:spPr>
           <a:xfrm>
             <a:off x="504444" y="1577340"/>
-            <a:ext cx="11180064" cy="3608832"/>
+            <a:ext cx="11180064" cy="2584704"/>
           </a:xfrm>
           <a:prstGeom prst="rect">
             <a:avLst/>
@@ -9336,8 +9904,8 @@
         </p:nvSpPr>
         <p:spPr>
           <a:xfrm>
-            <a:off x="502920" y="5277612"/>
-            <a:ext cx="11183112" cy="711708"/>
+            <a:off x="502920" y="4253484"/>
+            <a:ext cx="11183112" cy="1735836"/>
           </a:xfrm>
           <a:prstGeom prst="rect">
             <a:avLst/>
@@ -9352,11 +9920,11 @@
           <a:p>
             <a:pPr>
               <a:spcAft>
-                <a:spcPts val="400"/>
+                <a:spcPts val="300"/>
               </a:spcAft>
             </a:pPr>
             <a:r>
-              <a:rPr sz="1700">
+              <a:rPr sz="1400">
                 <a:solidFill>
                   <a:srgbClr val="323130"/>
                 </a:solidFill>
@@ -9366,7 +9934,7 @@
               <a:t>• </a:t>
             </a:r>
             <a:r>
-              <a:rPr sz="1700" b="1">
+              <a:rPr sz="1400" b="1">
                 <a:solidFill>
                   <a:srgbClr val="323130"/>
                 </a:solidFill>
@@ -9376,7 +9944,7 @@
               <a:t>並列実行可能</a:t>
             </a:r>
             <a:r>
-              <a:rPr sz="1700">
+              <a:rPr sz="1400">
                 <a:solidFill>
                   <a:srgbClr val="323130"/>
                 </a:solidFill>
@@ -9386,7 +9954,7 @@
               <a:t>：</a:t>
             </a:r>
             <a:r>
-              <a:rPr sz="1400">
+              <a:rPr sz="1100">
                 <a:solidFill>
                   <a:srgbClr val="C7254E"/>
                 </a:solidFill>
@@ -9396,7 +9964,7 @@
               <a:t>--remote</a:t>
             </a:r>
             <a:r>
-              <a:rPr sz="1700">
+              <a:rPr sz="1400">
                 <a:solidFill>
                   <a:srgbClr val="323130"/>
                 </a:solidFill>
@@ -9409,11 +9977,11 @@
           <a:p>
             <a:pPr>
               <a:spcAft>
-                <a:spcPts val="400"/>
+                <a:spcPts val="300"/>
               </a:spcAft>
             </a:pPr>
             <a:r>
-              <a:rPr sz="1700">
+              <a:rPr sz="1400">
                 <a:solidFill>
                   <a:srgbClr val="323130"/>
                 </a:solidFill>
@@ -9426,11 +9994,11 @@
           <a:p>
             <a:pPr>
               <a:spcAft>
-                <a:spcPts val="400"/>
+                <a:spcPts val="300"/>
               </a:spcAft>
             </a:pPr>
             <a:r>
-              <a:rPr sz="1700">
+              <a:rPr sz="1400">
                 <a:solidFill>
                   <a:srgbClr val="323130"/>
                 </a:solidFill>
@@ -9440,7 +10008,7 @@
               <a:t>• </a:t>
             </a:r>
             <a:r>
-              <a:rPr sz="1700" b="1">
+              <a:rPr sz="1400" b="1">
                 <a:solidFill>
                   <a:srgbClr val="323130"/>
                 </a:solidFill>
@@ -9450,7 +10018,7 @@
               <a:t>クラウド実行時</a:t>
             </a:r>
             <a:r>
-              <a:rPr sz="1700">
+              <a:rPr sz="1400">
                 <a:solidFill>
                   <a:srgbClr val="323130"/>
                 </a:solidFill>
@@ -9460,7 +10028,7 @@
               <a:t>: </a:t>
             </a:r>
             <a:r>
-              <a:rPr sz="1700" b="1">
+              <a:rPr sz="1400" b="1">
                 <a:solidFill>
                   <a:srgbClr val="323130"/>
                 </a:solidFill>
@@ -9470,7 +10038,7 @@
               <a:t>モデル</a:t>
             </a:r>
             <a:r>
-              <a:rPr sz="1700">
+              <a:rPr sz="1400">
                 <a:solidFill>
                   <a:srgbClr val="323130"/>
                 </a:solidFill>
@@ -9480,8 +10048,48 @@
               <a:t> </a:t>
             </a:r>
             <a:r>
+              <a:rPr sz="1100" b="1">
+                <a:solidFill>
+                  <a:srgbClr val="C62828"/>
+                </a:solidFill>
+                <a:latin typeface="Meiryo"/>
+                <a:ea typeface="Meiryo"/>
+              </a:rPr>
+              <a:t>SaaS</a:t>
+            </a:r>
+            <a:r>
+              <a:rPr sz="1400">
+                <a:solidFill>
+                  <a:srgbClr val="323130"/>
+                </a:solidFill>
+                <a:latin typeface="Meiryo"/>
+                <a:ea typeface="Meiryo"/>
+              </a:rPr>
+              <a:t> / </a:t>
+            </a:r>
+            <a:r>
               <a:rPr sz="1400" b="1">
                 <a:solidFill>
+                  <a:srgbClr val="323130"/>
+                </a:solidFill>
+                <a:latin typeface="Meiryo"/>
+                <a:ea typeface="Meiryo"/>
+              </a:rPr>
+              <a:t>エージェントソフト</a:t>
+            </a:r>
+            <a:r>
+              <a:rPr sz="1400">
+                <a:solidFill>
+                  <a:srgbClr val="323130"/>
+                </a:solidFill>
+                <a:latin typeface="Meiryo"/>
+                <a:ea typeface="Meiryo"/>
+              </a:rPr>
+              <a:t> </a:t>
+            </a:r>
+            <a:r>
+              <a:rPr sz="1100" b="1">
+                <a:solidFill>
                   <a:srgbClr val="C62828"/>
                 </a:solidFill>
                 <a:latin typeface="Meiryo"/>
@@ -9490,7 +10098,7 @@
               <a:t>SaaS</a:t>
             </a:r>
             <a:r>
-              <a:rPr sz="1700">
+              <a:rPr sz="1400">
                 <a:solidFill>
                   <a:srgbClr val="323130"/>
                 </a:solidFill>
@@ -9500,17 +10108,17 @@
               <a:t> / </a:t>
             </a:r>
             <a:r>
-              <a:rPr sz="1700" b="1">
-                <a:solidFill>
-                  <a:srgbClr val="323130"/>
-                </a:solidFill>
-                <a:latin typeface="Meiryo"/>
-                <a:ea typeface="Meiryo"/>
-              </a:rPr>
-              <a:t>エージェントソフト</a:t>
-            </a:r>
-            <a:r>
-              <a:rPr sz="1700">
+              <a:rPr sz="1400" b="1">
+                <a:solidFill>
+                  <a:srgbClr val="323130"/>
+                </a:solidFill>
+                <a:latin typeface="Meiryo"/>
+                <a:ea typeface="Meiryo"/>
+              </a:rPr>
+              <a:t>コンテキスト</a:t>
+            </a:r>
+            <a:r>
+              <a:rPr sz="1400">
                 <a:solidFill>
                   <a:srgbClr val="323130"/>
                 </a:solidFill>
@@ -9520,7 +10128,7 @@
               <a:t> </a:t>
             </a:r>
             <a:r>
-              <a:rPr sz="1400" b="1">
+              <a:rPr sz="1100" b="1">
                 <a:solidFill>
                   <a:srgbClr val="C62828"/>
                 </a:solidFill>
@@ -9530,47 +10138,7 @@
               <a:t>SaaS</a:t>
             </a:r>
             <a:r>
-              <a:rPr sz="1700">
-                <a:solidFill>
-                  <a:srgbClr val="323130"/>
-                </a:solidFill>
-                <a:latin typeface="Meiryo"/>
-                <a:ea typeface="Meiryo"/>
-              </a:rPr>
-              <a:t> / </a:t>
-            </a:r>
-            <a:r>
-              <a:rPr sz="1700" b="1">
-                <a:solidFill>
-                  <a:srgbClr val="323130"/>
-                </a:solidFill>
-                <a:latin typeface="Meiryo"/>
-                <a:ea typeface="Meiryo"/>
-              </a:rPr>
-              <a:t>コンテキスト</a:t>
-            </a:r>
-            <a:r>
-              <a:rPr sz="1700">
-                <a:solidFill>
-                  <a:srgbClr val="323130"/>
-                </a:solidFill>
-                <a:latin typeface="Meiryo"/>
-                <a:ea typeface="Meiryo"/>
-              </a:rPr>
-              <a:t> </a:t>
-            </a:r>
-            <a:r>
-              <a:rPr sz="1400" b="1">
-                <a:solidFill>
-                  <a:srgbClr val="C62828"/>
-                </a:solidFill>
-                <a:latin typeface="Meiryo"/>
-                <a:ea typeface="Meiryo"/>
-              </a:rPr>
-              <a:t>SaaS</a:t>
-            </a:r>
-            <a:r>
-              <a:rPr sz="1700">
+              <a:rPr sz="1400">
                 <a:solidFill>
                   <a:srgbClr val="323130"/>
                 </a:solidFill>
@@ -9583,11 +10151,11 @@
           <a:p>
             <a:pPr>
               <a:spcAft>
-                <a:spcPts val="400"/>
+                <a:spcPts val="300"/>
               </a:spcAft>
             </a:pPr>
             <a:r>
-              <a:rPr sz="1700">
+              <a:rPr sz="1400">
                 <a:solidFill>
                   <a:srgbClr val="323130"/>
                 </a:solidFill>
@@ -9597,7 +10165,7 @@
               <a:t>• </a:t>
             </a:r>
             <a:r>
-              <a:rPr sz="1700" b="1">
+              <a:rPr sz="1400" b="1">
                 <a:solidFill>
                   <a:srgbClr val="323130"/>
                 </a:solidFill>
@@ -9607,7 +10175,7 @@
               <a:t>teleport後</a:t>
             </a:r>
             <a:r>
-              <a:rPr sz="1700">
+              <a:rPr sz="1400">
                 <a:solidFill>
                   <a:srgbClr val="323130"/>
                 </a:solidFill>
@@ -9617,7 +10185,7 @@
               <a:t>: </a:t>
             </a:r>
             <a:r>
-              <a:rPr sz="1700" b="1">
+              <a:rPr sz="1400" b="1">
                 <a:solidFill>
                   <a:srgbClr val="323130"/>
                 </a:solidFill>
@@ -9627,7 +10195,7 @@
               <a:t>モデル</a:t>
             </a:r>
             <a:r>
-              <a:rPr sz="1700">
+              <a:rPr sz="1400">
                 <a:solidFill>
                   <a:srgbClr val="323130"/>
                 </a:solidFill>
@@ -9637,17 +10205,57 @@
               <a:t> </a:t>
             </a:r>
             <a:r>
+              <a:rPr sz="1100" b="1">
+                <a:solidFill>
+                  <a:srgbClr val="C62828"/>
+                </a:solidFill>
+                <a:latin typeface="Meiryo"/>
+                <a:ea typeface="Meiryo"/>
+              </a:rPr>
+              <a:t>SaaS</a:t>
+            </a:r>
+            <a:r>
+              <a:rPr sz="1400">
+                <a:solidFill>
+                  <a:srgbClr val="323130"/>
+                </a:solidFill>
+                <a:latin typeface="Meiryo"/>
+                <a:ea typeface="Meiryo"/>
+              </a:rPr>
+              <a:t> / </a:t>
+            </a:r>
+            <a:r>
               <a:rPr sz="1400" b="1">
                 <a:solidFill>
-                  <a:srgbClr val="C62828"/>
-                </a:solidFill>
-                <a:latin typeface="Meiryo"/>
-                <a:ea typeface="Meiryo"/>
-              </a:rPr>
-              <a:t>SaaS</a:t>
-            </a:r>
-            <a:r>
-              <a:rPr sz="1700">
+                  <a:srgbClr val="323130"/>
+                </a:solidFill>
+                <a:latin typeface="Meiryo"/>
+                <a:ea typeface="Meiryo"/>
+              </a:rPr>
+              <a:t>エージェントソフト</a:t>
+            </a:r>
+            <a:r>
+              <a:rPr sz="1400">
+                <a:solidFill>
+                  <a:srgbClr val="323130"/>
+                </a:solidFill>
+                <a:latin typeface="Meiryo"/>
+                <a:ea typeface="Meiryo"/>
+              </a:rPr>
+              <a:t> </a:t>
+            </a:r>
+            <a:r>
+              <a:rPr sz="1100" b="1">
+                <a:solidFill>
+                  <a:srgbClr val="2E7D32"/>
+                </a:solidFill>
+                <a:latin typeface="Meiryo"/>
+                <a:ea typeface="Meiryo"/>
+              </a:rPr>
+              <a:t>オンプレ</a:t>
+            </a:r>
+            <a:r>
+              <a:rPr sz="1400">
                 <a:solidFill>
                   <a:srgbClr val="323130"/>
                 </a:solidFill>
@@ -9657,17 +10265,17 @@
               <a:t> / </a:t>
             </a:r>
             <a:r>
-              <a:rPr sz="1700" b="1">
-                <a:solidFill>
-                  <a:srgbClr val="323130"/>
-                </a:solidFill>
-                <a:latin typeface="Meiryo"/>
-                <a:ea typeface="Meiryo"/>
-              </a:rPr>
-              <a:t>エージェントソフト</a:t>
-            </a:r>
-            <a:r>
-              <a:rPr sz="1700">
+              <a:rPr sz="1400" b="1">
+                <a:solidFill>
+                  <a:srgbClr val="323130"/>
+                </a:solidFill>
+                <a:latin typeface="Meiryo"/>
+                <a:ea typeface="Meiryo"/>
+              </a:rPr>
+              <a:t>コンテキスト</a:t>
+            </a:r>
+            <a:r>
+              <a:rPr sz="1400">
                 <a:solidFill>
                   <a:srgbClr val="323130"/>
                 </a:solidFill>
@@ -9677,7 +10285,7 @@
               <a:t> </a:t>
             </a:r>
             <a:r>
-              <a:rPr sz="1400" b="1">
+              <a:rPr sz="1100" b="1">
                 <a:solidFill>
                   <a:srgbClr val="2E7D32"/>
                 </a:solidFill>
@@ -9687,47 +10295,7 @@
               <a:t>オンプレ</a:t>
             </a:r>
             <a:r>
-              <a:rPr sz="1700">
-                <a:solidFill>
-                  <a:srgbClr val="323130"/>
-                </a:solidFill>
-                <a:latin typeface="Meiryo"/>
-                <a:ea typeface="Meiryo"/>
-              </a:rPr>
-              <a:t> / </a:t>
-            </a:r>
-            <a:r>
-              <a:rPr sz="1700" b="1">
-                <a:solidFill>
-                  <a:srgbClr val="323130"/>
-                </a:solidFill>
-                <a:latin typeface="Meiryo"/>
-                <a:ea typeface="Meiryo"/>
-              </a:rPr>
-              <a:t>コンテキスト</a:t>
-            </a:r>
-            <a:r>
-              <a:rPr sz="1700">
-                <a:solidFill>
-                  <a:srgbClr val="323130"/>
-                </a:solidFill>
-                <a:latin typeface="Meiryo"/>
-                <a:ea typeface="Meiryo"/>
-              </a:rPr>
-              <a:t> </a:t>
-            </a:r>
-            <a:r>
-              <a:rPr sz="1400" b="1">
-                <a:solidFill>
-                  <a:srgbClr val="2E7D32"/>
-                </a:solidFill>
-                <a:latin typeface="Meiryo"/>
-                <a:ea typeface="Meiryo"/>
-              </a:rPr>
-              <a:t>オンプレ</a:t>
-            </a:r>
-            <a:r>
-              <a:rPr sz="1700">
+              <a:rPr sz="1400">
                 <a:solidFill>
                   <a:srgbClr val="323130"/>
                 </a:solidFill>
@@ -9737,7 +10305,7 @@
               <a:t> + </a:t>
             </a:r>
             <a:r>
-              <a:rPr sz="1400" b="1">
+              <a:rPr sz="1100" b="1">
                 <a:solidFill>
                   <a:srgbClr val="C62828"/>
                 </a:solidFill>
@@ -9750,11 +10318,11 @@
           <a:p>
             <a:pPr>
               <a:spcAft>
-                <a:spcPts val="400"/>
+                <a:spcPts val="300"/>
               </a:spcAft>
             </a:pPr>
             <a:r>
-              <a:rPr sz="1700">
+              <a:rPr sz="1400">
                 <a:solidFill>
                   <a:srgbClr val="323130"/>
                 </a:solidFill>
@@ -16129,7 +16697,7 @@
         <p:spPr>
           <a:xfrm>
             <a:off x="504444" y="1577340"/>
-            <a:ext cx="11180064" cy="3608832"/>
+            <a:ext cx="11180064" cy="3093720"/>
           </a:xfrm>
           <a:prstGeom prst="rect">
             <a:avLst/>
@@ -16144,8 +16712,8 @@
         </p:nvSpPr>
         <p:spPr>
           <a:xfrm>
-            <a:off x="502920" y="5277612"/>
-            <a:ext cx="11183112" cy="711708"/>
+            <a:off x="502920" y="4762500"/>
+            <a:ext cx="11183112" cy="1226819"/>
           </a:xfrm>
           <a:prstGeom prst="rect">
             <a:avLst/>

</xml_diff>